<commit_message>
feat: add simple custom node example and update presentation
</commit_message>
<xml_diff>
--- a/Vue-Flow-Simple-Tutorial.pptx
+++ b/Vue-Flow-Simple-Tutorial.pptx
@@ -3211,7 +3211,7 @@
               </a:defRPr>
             </a:pPr>
             <a:r>
-              <a:t>核心概念與基礎互動範例</a:t>
+              <a:t>包含自定義節點的互動流程圖開發</a:t>
             </a:r>
           </a:p>
         </p:txBody>
@@ -3290,11 +3290,11 @@
               </a:defRPr>
             </a:pPr>
             <a:r>
-              <a:t>使用 @vue-flow/core 來實作極簡的有向圖與流程圖</a:t>
+              <a:t>使用 @vue-flow/core 實作極簡的有向圖與流程圖</a:t>
             </a:r>
             <a:br/>
             <a:r>
-              <a:t>本教學專注於内建節點與最基礎的動態連線邏輯</a:t>
+              <a:t>本教學專注於內建三種節點、自定義節點與基本動態連線邏輯</a:t>
             </a:r>
           </a:p>
         </p:txBody>
@@ -3542,7 +3542,7 @@
               </a:defRPr>
             </a:pPr>
             <a:r>
-              <a:t>01  VUE FLOW ARCHITECTURE</a:t>
+              <a:t>01  VUE FLOW BASICS</a:t>
             </a:r>
           </a:p>
         </p:txBody>
@@ -3578,7 +3578,7 @@
               </a:defRPr>
             </a:pPr>
             <a:r>
-              <a:t>核心物件與運作機制</a:t>
+              <a:t>核心概念與內建節點</a:t>
             </a:r>
           </a:p>
         </p:txBody>
@@ -3635,7 +3635,7 @@
         <p:spPr>
           <a:xfrm>
             <a:off x="731520" y="2011680"/>
-            <a:ext cx="10515600" cy="4114800"/>
+            <a:ext cx="5486400" cy="4114800"/>
           </a:xfrm>
           <a:prstGeom prst="rect">
             <a:avLst/>
@@ -3650,14 +3650,14 @@
           <a:p>
             <a:pPr>
               <a:spcBef>
-                <a:spcPts val="600"/>
-              </a:spcBef>
-              <a:spcAft>
-                <a:spcPts val="400"/>
-              </a:spcAft>
-            </a:pPr>
-            <a:r>
-              <a:rPr sz="1600">
+                <a:spcPts val="500"/>
+              </a:spcBef>
+              <a:spcAft>
+                <a:spcPts val="300"/>
+              </a:spcAft>
+            </a:pPr>
+            <a:r>
+              <a:rPr sz="1500">
                 <a:solidFill>
                   <a:srgbClr val="10B981"/>
                 </a:solidFill>
@@ -3665,7 +3665,7 @@
               <a:t>📍  </a:t>
             </a:r>
             <a:r>
-              <a:rPr sz="1600" b="1">
+              <a:rPr sz="1500" b="1">
                 <a:solidFill>
                   <a:srgbClr val="F8FAFC"/>
                 </a:solidFill>
@@ -3673,25 +3673,25 @@
               <a:t>Nodes (節點)</a:t>
             </a:r>
             <a:r>
-              <a:rPr sz="1450">
+              <a:rPr sz="1350">
                 <a:solidFill>
                   <a:srgbClr val="94A3B8"/>
                 </a:solidFill>
               </a:rPr>
-              <a:t>  —  流程圖中的主體方塊。包含 id、座標 position、文字標籤 label、型別 type 等。</a:t>
-            </a:r>
-          </a:p>
-          <a:p>
-            <a:pPr>
-              <a:spcBef>
-                <a:spcPts val="600"/>
-              </a:spcBef>
-              <a:spcAft>
-                <a:spcPts val="400"/>
-              </a:spcAft>
-            </a:pPr>
-            <a:r>
-              <a:rPr sz="1600">
+              <a:t>  —  流程圖中的方塊，包含 id, position (座標), label (標籤), type (類型)。</a:t>
+            </a:r>
+          </a:p>
+          <a:p>
+            <a:pPr>
+              <a:spcBef>
+                <a:spcPts val="500"/>
+              </a:spcBef>
+              <a:spcAft>
+                <a:spcPts val="300"/>
+              </a:spcAft>
+            </a:pPr>
+            <a:r>
+              <a:rPr sz="1500">
                 <a:solidFill>
                   <a:srgbClr val="10B981"/>
                 </a:solidFill>
@@ -3699,7 +3699,7 @@
               <a:t>⚡  </a:t>
             </a:r>
             <a:r>
-              <a:rPr sz="1600" b="1">
+              <a:rPr sz="1500" b="1">
                 <a:solidFill>
                   <a:srgbClr val="F8FAFC"/>
                 </a:solidFill>
@@ -3707,25 +3707,25 @@
               <a:t>Edges (連線/邊)</a:t>
             </a:r>
             <a:r>
-              <a:rPr sz="1450">
+              <a:rPr sz="1350">
                 <a:solidFill>
                   <a:srgbClr val="94A3B8"/>
                 </a:solidFill>
               </a:rPr>
-              <a:t>  —  連接著兩個節點的有向線段。具有 source (來源節點 id) 與 target (目標節點 id)。</a:t>
-            </a:r>
-          </a:p>
-          <a:p>
-            <a:pPr>
-              <a:spcBef>
-                <a:spcPts val="600"/>
-              </a:spcBef>
-              <a:spcAft>
-                <a:spcPts val="400"/>
-              </a:spcAft>
-            </a:pPr>
-            <a:r>
-              <a:rPr sz="1600">
+              <a:t>  —  連接著兩個節點的有向線段。具有 source 來源與 target 目標節點 id。</a:t>
+            </a:r>
+          </a:p>
+          <a:p>
+            <a:pPr>
+              <a:spcBef>
+                <a:spcPts val="500"/>
+              </a:spcBef>
+              <a:spcAft>
+                <a:spcPts val="300"/>
+              </a:spcAft>
+            </a:pPr>
+            <a:r>
+              <a:rPr sz="1500">
                 <a:solidFill>
                   <a:srgbClr val="10B981"/>
                 </a:solidFill>
@@ -3733,7 +3733,7 @@
               <a:t>🔵  </a:t>
             </a:r>
             <a:r>
-              <a:rPr sz="1600" b="1">
+              <a:rPr sz="1500" b="1">
                 <a:solidFill>
                   <a:srgbClr val="F8FAFC"/>
                 </a:solidFill>
@@ -3741,46 +3741,219 @@
               <a:t>Handles (連接點)</a:t>
             </a:r>
             <a:r>
-              <a:rPr sz="1450">
+              <a:rPr sz="1350">
                 <a:solidFill>
                   <a:srgbClr val="94A3B8"/>
                 </a:solidFill>
               </a:rPr>
-              <a:t>  —  節點內部的接口，分為 target (輸入，通常在左/上) 與 source (輸出，通常在右/下)。</a:t>
-            </a:r>
-          </a:p>
-          <a:p>
-            <a:pPr>
-              <a:spcBef>
-                <a:spcPts val="600"/>
-              </a:spcBef>
-              <a:spcAft>
-                <a:spcPts val="400"/>
-              </a:spcAft>
-            </a:pPr>
-            <a:r>
-              <a:rPr sz="1600">
+              <a:t>  —  節點上的插座。有 target (輸入) 與 source (輸出) 兩種型態。</a:t>
+            </a:r>
+          </a:p>
+        </p:txBody>
+      </p:sp>
+      <p:sp>
+        <p:nvSpPr>
+          <p:cNvPr id="6" name="Rounded Rectangle 5"/>
+          <p:cNvSpPr/>
+          <p:nvPr/>
+        </p:nvSpPr>
+        <p:spPr>
+          <a:xfrm>
+            <a:off x="6583680" y="2011680"/>
+            <a:ext cx="4846320" cy="4114800"/>
+          </a:xfrm>
+          <a:prstGeom prst="roundRect">
+            <a:avLst>
+              <a:gd name="adj" fmla="val 5000"/>
+            </a:avLst>
+          </a:prstGeom>
+          <a:solidFill>
+            <a:srgbClr val="1E293B"/>
+          </a:solidFill>
+          <a:ln>
+            <a:noFill/>
+          </a:ln>
+          <a:effectLst/>
+        </p:spPr>
+        <p:style>
+          <a:lnRef idx="1">
+            <a:schemeClr val="accent1"/>
+          </a:lnRef>
+          <a:fillRef idx="3">
+            <a:schemeClr val="accent1"/>
+          </a:fillRef>
+          <a:effectRef idx="2">
+            <a:schemeClr val="accent1"/>
+          </a:effectRef>
+          <a:fontRef idx="minor">
+            <a:schemeClr val="lt1"/>
+          </a:fontRef>
+        </p:style>
+        <p:txBody>
+          <a:bodyPr rtlCol="0" anchor="ctr"/>
+          <a:lstStyle/>
+          <a:p>
+            <a:pPr algn="ctr"/>
+          </a:p>
+        </p:txBody>
+      </p:sp>
+      <p:sp>
+        <p:nvSpPr>
+          <p:cNvPr id="7" name="TextBox 6"/>
+          <p:cNvSpPr txBox="1"/>
+          <p:nvPr/>
+        </p:nvSpPr>
+        <p:spPr>
+          <a:xfrm>
+            <a:off x="6858000" y="2194560"/>
+            <a:ext cx="4297680" cy="365760"/>
+          </a:xfrm>
+          <a:prstGeom prst="rect">
+            <a:avLst/>
+          </a:prstGeom>
+          <a:noFill/>
+        </p:spPr>
+        <p:txBody>
+          <a:bodyPr wrap="square">
+            <a:spAutoFit/>
+          </a:bodyPr>
+          <a:lstStyle/>
+          <a:p>
+            <a:pPr algn="l">
+              <a:defRPr sz="1800" b="1">
+                <a:solidFill>
+                  <a:srgbClr val="F8FAFC"/>
+                </a:solidFill>
+                <a:latin typeface="Calibri"/>
+              </a:defRPr>
+            </a:pPr>
+            <a:r>
+              <a:t>三種官方內建節點</a:t>
+            </a:r>
+          </a:p>
+        </p:txBody>
+      </p:sp>
+      <p:sp>
+        <p:nvSpPr>
+          <p:cNvPr id="8" name="TextBox 7"/>
+          <p:cNvSpPr txBox="1"/>
+          <p:nvPr/>
+        </p:nvSpPr>
+        <p:spPr>
+          <a:xfrm>
+            <a:off x="6858000" y="2651760"/>
+            <a:ext cx="4297680" cy="3200400"/>
+          </a:xfrm>
+          <a:prstGeom prst="rect">
+            <a:avLst/>
+          </a:prstGeom>
+          <a:noFill/>
+        </p:spPr>
+        <p:txBody>
+          <a:bodyPr wrap="square">
+            <a:spAutoFit/>
+          </a:bodyPr>
+          <a:lstStyle/>
+          <a:p>
+            <a:pPr>
+              <a:spcBef>
+                <a:spcPts val="500"/>
+              </a:spcBef>
+              <a:spcAft>
+                <a:spcPts val="300"/>
+              </a:spcAft>
+            </a:pPr>
+            <a:r>
+              <a:rPr sz="1400">
                 <a:solidFill>
                   <a:srgbClr val="10B981"/>
                 </a:solidFill>
               </a:rPr>
-              <a:t>🌊  </a:t>
-            </a:r>
-            <a:r>
-              <a:rPr sz="1600" b="1">
+              <a:t>🟢  </a:t>
+            </a:r>
+            <a:r>
+              <a:rPr sz="1400" b="1">
                 <a:solidFill>
                   <a:srgbClr val="F8FAFC"/>
                 </a:solidFill>
               </a:rPr>
-              <a:t>VueFlow 容器</a:t>
-            </a:r>
-            <a:r>
-              <a:rPr sz="1450">
+              <a:t>input (輸入節點)</a:t>
+            </a:r>
+            <a:r>
+              <a:rPr sz="1250">
                 <a:solidFill>
                   <a:srgbClr val="94A3B8"/>
                 </a:solidFill>
               </a:rPr>
-              <a:t>  —  頂層的 Vue 元件。必須賦予其固定的寬高 (如 100vh / 100%)，否則畫布無法正常渲染。</a:t>
+              <a:t>  —  僅具備 source 輸出連接孔，常用作工作流起始點。</a:t>
+            </a:r>
+          </a:p>
+          <a:p>
+            <a:pPr>
+              <a:spcBef>
+                <a:spcPts val="500"/>
+              </a:spcBef>
+              <a:spcAft>
+                <a:spcPts val="300"/>
+              </a:spcAft>
+            </a:pPr>
+            <a:r>
+              <a:rPr sz="1400">
+                <a:solidFill>
+                  <a:srgbClr val="10B981"/>
+                </a:solidFill>
+              </a:rPr>
+              <a:t>🔵  </a:t>
+            </a:r>
+            <a:r>
+              <a:rPr sz="1400" b="1">
+                <a:solidFill>
+                  <a:srgbClr val="F8FAFC"/>
+                </a:solidFill>
+              </a:rPr>
+              <a:t>default (預設節點)</a:t>
+            </a:r>
+            <a:r>
+              <a:rPr sz="1250">
+                <a:solidFill>
+                  <a:srgbClr val="94A3B8"/>
+                </a:solidFill>
+              </a:rPr>
+              <a:t>  —  具備 input 與 output 兩端點，用於流程的中繼站。</a:t>
+            </a:r>
+          </a:p>
+          <a:p>
+            <a:pPr>
+              <a:spcBef>
+                <a:spcPts val="500"/>
+              </a:spcBef>
+              <a:spcAft>
+                <a:spcPts val="300"/>
+              </a:spcAft>
+            </a:pPr>
+            <a:r>
+              <a:rPr sz="1400">
+                <a:solidFill>
+                  <a:srgbClr val="10B981"/>
+                </a:solidFill>
+              </a:rPr>
+              <a:t>🔴  </a:t>
+            </a:r>
+            <a:r>
+              <a:rPr sz="1400" b="1">
+                <a:solidFill>
+                  <a:srgbClr val="F8FAFC"/>
+                </a:solidFill>
+              </a:rPr>
+              <a:t>output (輸出節點)</a:t>
+            </a:r>
+            <a:r>
+              <a:rPr sz="1250">
+                <a:solidFill>
+                  <a:srgbClr val="94A3B8"/>
+                </a:solidFill>
+              </a:rPr>
+              <a:t>  —  僅具備 target 輸入連接孔，常用作工作流終點。</a:t>
             </a:r>
           </a:p>
         </p:txBody>
@@ -3842,7 +4015,7 @@
               </a:defRPr>
             </a:pPr>
             <a:r>
-              <a:t>02  BUILT-IN NODE TYPES</a:t>
+              <a:t>02  QUICK INTEGRATION</a:t>
             </a:r>
           </a:p>
         </p:txBody>
@@ -3878,7 +4051,7 @@
               </a:defRPr>
             </a:pPr>
             <a:r>
-              <a:t>三種基礎的內建節點</a:t>
+              <a:t>環境配置與快速啟用</a:t>
             </a:r>
           </a:p>
         </p:txBody>
@@ -3928,867 +4101,6 @@
       </p:sp>
       <p:sp>
         <p:nvSpPr>
-          <p:cNvPr id="5" name="Rounded Rectangle 4"/>
-          <p:cNvSpPr/>
-          <p:nvPr/>
-        </p:nvSpPr>
-        <p:spPr>
-          <a:xfrm>
-            <a:off x="731520" y="2103120"/>
-            <a:ext cx="3383280" cy="3840480"/>
-          </a:xfrm>
-          <a:prstGeom prst="roundRect">
-            <a:avLst>
-              <a:gd name="adj" fmla="val 5000"/>
-            </a:avLst>
-          </a:prstGeom>
-          <a:solidFill>
-            <a:srgbClr val="1E293B"/>
-          </a:solidFill>
-          <a:ln>
-            <a:noFill/>
-          </a:ln>
-          <a:effectLst/>
-        </p:spPr>
-        <p:style>
-          <a:lnRef idx="1">
-            <a:schemeClr val="accent1"/>
-          </a:lnRef>
-          <a:fillRef idx="3">
-            <a:schemeClr val="accent1"/>
-          </a:fillRef>
-          <a:effectRef idx="2">
-            <a:schemeClr val="accent1"/>
-          </a:effectRef>
-          <a:fontRef idx="minor">
-            <a:schemeClr val="lt1"/>
-          </a:fontRef>
-        </p:style>
-        <p:txBody>
-          <a:bodyPr rtlCol="0" anchor="ctr"/>
-          <a:lstStyle/>
-          <a:p>
-            <a:pPr algn="ctr"/>
-          </a:p>
-        </p:txBody>
-      </p:sp>
-      <p:sp>
-        <p:nvSpPr>
-          <p:cNvPr id="6" name="Rectangle 5"/>
-          <p:cNvSpPr/>
-          <p:nvPr/>
-        </p:nvSpPr>
-        <p:spPr>
-          <a:xfrm>
-            <a:off x="731520" y="2103120"/>
-            <a:ext cx="3383280" cy="50800"/>
-          </a:xfrm>
-          <a:prstGeom prst="rect">
-            <a:avLst/>
-          </a:prstGeom>
-          <a:solidFill>
-            <a:srgbClr val="10B981"/>
-          </a:solidFill>
-          <a:ln>
-            <a:noFill/>
-          </a:ln>
-        </p:spPr>
-        <p:style>
-          <a:lnRef idx="1">
-            <a:schemeClr val="accent1"/>
-          </a:lnRef>
-          <a:fillRef idx="3">
-            <a:schemeClr val="accent1"/>
-          </a:fillRef>
-          <a:effectRef idx="2">
-            <a:schemeClr val="accent1"/>
-          </a:effectRef>
-          <a:fontRef idx="minor">
-            <a:schemeClr val="lt1"/>
-          </a:fontRef>
-        </p:style>
-        <p:txBody>
-          <a:bodyPr rtlCol="0" anchor="ctr"/>
-          <a:lstStyle/>
-          <a:p>
-            <a:pPr algn="ctr"/>
-          </a:p>
-        </p:txBody>
-      </p:sp>
-      <p:sp>
-        <p:nvSpPr>
-          <p:cNvPr id="7" name="TextBox 6"/>
-          <p:cNvSpPr txBox="1"/>
-          <p:nvPr/>
-        </p:nvSpPr>
-        <p:spPr>
-          <a:xfrm>
-            <a:off x="1005840" y="2377440"/>
-            <a:ext cx="2834640" cy="365760"/>
-          </a:xfrm>
-          <a:prstGeom prst="rect">
-            <a:avLst/>
-          </a:prstGeom>
-          <a:noFill/>
-        </p:spPr>
-        <p:txBody>
-          <a:bodyPr wrap="square">
-            <a:spAutoFit/>
-          </a:bodyPr>
-          <a:lstStyle/>
-          <a:p>
-            <a:pPr algn="l">
-              <a:defRPr sz="2000" b="1">
-                <a:solidFill>
-                  <a:srgbClr val="F8FAFC"/>
-                </a:solidFill>
-                <a:latin typeface="Calibri"/>
-              </a:defRPr>
-            </a:pPr>
-            <a:r>
-              <a:t>輸入節點 (input)</a:t>
-            </a:r>
-          </a:p>
-        </p:txBody>
-      </p:sp>
-      <p:sp>
-        <p:nvSpPr>
-          <p:cNvPr id="8" name="TextBox 7"/>
-          <p:cNvSpPr txBox="1"/>
-          <p:nvPr/>
-        </p:nvSpPr>
-        <p:spPr>
-          <a:xfrm>
-            <a:off x="1005840" y="2834640"/>
-            <a:ext cx="2834640" cy="274320"/>
-          </a:xfrm>
-          <a:prstGeom prst="rect">
-            <a:avLst/>
-          </a:prstGeom>
-          <a:noFill/>
-        </p:spPr>
-        <p:txBody>
-          <a:bodyPr wrap="square">
-            <a:spAutoFit/>
-          </a:bodyPr>
-          <a:lstStyle/>
-          <a:p>
-            <a:pPr algn="l">
-              <a:defRPr sz="1400" b="1">
-                <a:solidFill>
-                  <a:srgbClr val="10B981"/>
-                </a:solidFill>
-                <a:latin typeface="Calibri"/>
-              </a:defRPr>
-            </a:pPr>
-            <a:r>
-              <a:t>僅有 source 輸出點</a:t>
-            </a:r>
-          </a:p>
-        </p:txBody>
-      </p:sp>
-      <p:sp>
-        <p:nvSpPr>
-          <p:cNvPr id="9" name="Rectangle 8"/>
-          <p:cNvSpPr/>
-          <p:nvPr/>
-        </p:nvSpPr>
-        <p:spPr>
-          <a:xfrm>
-            <a:off x="1005840" y="3200400"/>
-            <a:ext cx="548640" cy="38100"/>
-          </a:xfrm>
-          <a:prstGeom prst="rect">
-            <a:avLst/>
-          </a:prstGeom>
-          <a:solidFill>
-            <a:srgbClr val="10B981"/>
-          </a:solidFill>
-          <a:ln>
-            <a:noFill/>
-          </a:ln>
-        </p:spPr>
-        <p:style>
-          <a:lnRef idx="1">
-            <a:schemeClr val="accent1"/>
-          </a:lnRef>
-          <a:fillRef idx="3">
-            <a:schemeClr val="accent1"/>
-          </a:fillRef>
-          <a:effectRef idx="2">
-            <a:schemeClr val="accent1"/>
-          </a:effectRef>
-          <a:fontRef idx="minor">
-            <a:schemeClr val="lt1"/>
-          </a:fontRef>
-        </p:style>
-        <p:txBody>
-          <a:bodyPr rtlCol="0" anchor="ctr"/>
-          <a:lstStyle/>
-          <a:p>
-            <a:pPr algn="ctr"/>
-          </a:p>
-        </p:txBody>
-      </p:sp>
-      <p:sp>
-        <p:nvSpPr>
-          <p:cNvPr id="10" name="TextBox 9"/>
-          <p:cNvSpPr txBox="1"/>
-          <p:nvPr/>
-        </p:nvSpPr>
-        <p:spPr>
-          <a:xfrm>
-            <a:off x="1005840" y="3383280"/>
-            <a:ext cx="2834640" cy="1828800"/>
-          </a:xfrm>
-          <a:prstGeom prst="rect">
-            <a:avLst/>
-          </a:prstGeom>
-          <a:noFill/>
-        </p:spPr>
-        <p:txBody>
-          <a:bodyPr wrap="square">
-            <a:spAutoFit/>
-          </a:bodyPr>
-          <a:lstStyle/>
-          <a:p>
-            <a:pPr algn="l">
-              <a:defRPr sz="1400" b="0">
-                <a:solidFill>
-                  <a:srgbClr val="94A3B8"/>
-                </a:solidFill>
-                <a:latin typeface="Calibri"/>
-              </a:defRPr>
-            </a:pPr>
-            <a:r>
-              <a:t>一般用於整個流程圖的起始點，例如「資料來源」或「起點」。</a:t>
-            </a:r>
-          </a:p>
-        </p:txBody>
-      </p:sp>
-      <p:sp>
-        <p:nvSpPr>
-          <p:cNvPr id="11" name="Rounded Rectangle 10"/>
-          <p:cNvSpPr/>
-          <p:nvPr/>
-        </p:nvSpPr>
-        <p:spPr>
-          <a:xfrm>
-            <a:off x="4389120" y="2103120"/>
-            <a:ext cx="3383280" cy="3840480"/>
-          </a:xfrm>
-          <a:prstGeom prst="roundRect">
-            <a:avLst>
-              <a:gd name="adj" fmla="val 5000"/>
-            </a:avLst>
-          </a:prstGeom>
-          <a:solidFill>
-            <a:srgbClr val="1E293B"/>
-          </a:solidFill>
-          <a:ln>
-            <a:noFill/>
-          </a:ln>
-          <a:effectLst/>
-        </p:spPr>
-        <p:style>
-          <a:lnRef idx="1">
-            <a:schemeClr val="accent1"/>
-          </a:lnRef>
-          <a:fillRef idx="3">
-            <a:schemeClr val="accent1"/>
-          </a:fillRef>
-          <a:effectRef idx="2">
-            <a:schemeClr val="accent1"/>
-          </a:effectRef>
-          <a:fontRef idx="minor">
-            <a:schemeClr val="lt1"/>
-          </a:fontRef>
-        </p:style>
-        <p:txBody>
-          <a:bodyPr rtlCol="0" anchor="ctr"/>
-          <a:lstStyle/>
-          <a:p>
-            <a:pPr algn="ctr"/>
-          </a:p>
-        </p:txBody>
-      </p:sp>
-      <p:sp>
-        <p:nvSpPr>
-          <p:cNvPr id="12" name="Rectangle 11"/>
-          <p:cNvSpPr/>
-          <p:nvPr/>
-        </p:nvSpPr>
-        <p:spPr>
-          <a:xfrm>
-            <a:off x="4389120" y="2103120"/>
-            <a:ext cx="3383280" cy="50800"/>
-          </a:xfrm>
-          <a:prstGeom prst="rect">
-            <a:avLst/>
-          </a:prstGeom>
-          <a:solidFill>
-            <a:srgbClr val="6366F1"/>
-          </a:solidFill>
-          <a:ln>
-            <a:noFill/>
-          </a:ln>
-        </p:spPr>
-        <p:style>
-          <a:lnRef idx="1">
-            <a:schemeClr val="accent1"/>
-          </a:lnRef>
-          <a:fillRef idx="3">
-            <a:schemeClr val="accent1"/>
-          </a:fillRef>
-          <a:effectRef idx="2">
-            <a:schemeClr val="accent1"/>
-          </a:effectRef>
-          <a:fontRef idx="minor">
-            <a:schemeClr val="lt1"/>
-          </a:fontRef>
-        </p:style>
-        <p:txBody>
-          <a:bodyPr rtlCol="0" anchor="ctr"/>
-          <a:lstStyle/>
-          <a:p>
-            <a:pPr algn="ctr"/>
-          </a:p>
-        </p:txBody>
-      </p:sp>
-      <p:sp>
-        <p:nvSpPr>
-          <p:cNvPr id="13" name="TextBox 12"/>
-          <p:cNvSpPr txBox="1"/>
-          <p:nvPr/>
-        </p:nvSpPr>
-        <p:spPr>
-          <a:xfrm>
-            <a:off x="4663440" y="2377440"/>
-            <a:ext cx="2834640" cy="365760"/>
-          </a:xfrm>
-          <a:prstGeom prst="rect">
-            <a:avLst/>
-          </a:prstGeom>
-          <a:noFill/>
-        </p:spPr>
-        <p:txBody>
-          <a:bodyPr wrap="square">
-            <a:spAutoFit/>
-          </a:bodyPr>
-          <a:lstStyle/>
-          <a:p>
-            <a:pPr algn="l">
-              <a:defRPr sz="2000" b="1">
-                <a:solidFill>
-                  <a:srgbClr val="F8FAFC"/>
-                </a:solidFill>
-                <a:latin typeface="Calibri"/>
-              </a:defRPr>
-            </a:pPr>
-            <a:r>
-              <a:t>預設節點 (default)</a:t>
-            </a:r>
-          </a:p>
-        </p:txBody>
-      </p:sp>
-      <p:sp>
-        <p:nvSpPr>
-          <p:cNvPr id="14" name="TextBox 13"/>
-          <p:cNvSpPr txBox="1"/>
-          <p:nvPr/>
-        </p:nvSpPr>
-        <p:spPr>
-          <a:xfrm>
-            <a:off x="4663440" y="2834640"/>
-            <a:ext cx="2834640" cy="274320"/>
-          </a:xfrm>
-          <a:prstGeom prst="rect">
-            <a:avLst/>
-          </a:prstGeom>
-          <a:noFill/>
-        </p:spPr>
-        <p:txBody>
-          <a:bodyPr wrap="square">
-            <a:spAutoFit/>
-          </a:bodyPr>
-          <a:lstStyle/>
-          <a:p>
-            <a:pPr algn="l">
-              <a:defRPr sz="1400" b="1">
-                <a:solidFill>
-                  <a:srgbClr val="6366F1"/>
-                </a:solidFill>
-                <a:latin typeface="Calibri"/>
-              </a:defRPr>
-            </a:pPr>
-            <a:r>
-              <a:t>具備 input 與 output 兩端點</a:t>
-            </a:r>
-          </a:p>
-        </p:txBody>
-      </p:sp>
-      <p:sp>
-        <p:nvSpPr>
-          <p:cNvPr id="15" name="Rectangle 14"/>
-          <p:cNvSpPr/>
-          <p:nvPr/>
-        </p:nvSpPr>
-        <p:spPr>
-          <a:xfrm>
-            <a:off x="4663440" y="3200400"/>
-            <a:ext cx="548640" cy="38100"/>
-          </a:xfrm>
-          <a:prstGeom prst="rect">
-            <a:avLst/>
-          </a:prstGeom>
-          <a:solidFill>
-            <a:srgbClr val="6366F1"/>
-          </a:solidFill>
-          <a:ln>
-            <a:noFill/>
-          </a:ln>
-        </p:spPr>
-        <p:style>
-          <a:lnRef idx="1">
-            <a:schemeClr val="accent1"/>
-          </a:lnRef>
-          <a:fillRef idx="3">
-            <a:schemeClr val="accent1"/>
-          </a:fillRef>
-          <a:effectRef idx="2">
-            <a:schemeClr val="accent1"/>
-          </a:effectRef>
-          <a:fontRef idx="minor">
-            <a:schemeClr val="lt1"/>
-          </a:fontRef>
-        </p:style>
-        <p:txBody>
-          <a:bodyPr rtlCol="0" anchor="ctr"/>
-          <a:lstStyle/>
-          <a:p>
-            <a:pPr algn="ctr"/>
-          </a:p>
-        </p:txBody>
-      </p:sp>
-      <p:sp>
-        <p:nvSpPr>
-          <p:cNvPr id="16" name="TextBox 15"/>
-          <p:cNvSpPr txBox="1"/>
-          <p:nvPr/>
-        </p:nvSpPr>
-        <p:spPr>
-          <a:xfrm>
-            <a:off x="4663440" y="3383280"/>
-            <a:ext cx="2834640" cy="1828800"/>
-          </a:xfrm>
-          <a:prstGeom prst="rect">
-            <a:avLst/>
-          </a:prstGeom>
-          <a:noFill/>
-        </p:spPr>
-        <p:txBody>
-          <a:bodyPr wrap="square">
-            <a:spAutoFit/>
-          </a:bodyPr>
-          <a:lstStyle/>
-          <a:p>
-            <a:pPr algn="l">
-              <a:defRPr sz="1400" b="0">
-                <a:solidFill>
-                  <a:srgbClr val="94A3B8"/>
-                </a:solidFill>
-                <a:latin typeface="Calibri"/>
-              </a:defRPr>
-            </a:pPr>
-            <a:r>
-              <a:t>最普遍的節點，用於進行資料運算、轉換等中間過程。</a:t>
-            </a:r>
-          </a:p>
-        </p:txBody>
-      </p:sp>
-      <p:sp>
-        <p:nvSpPr>
-          <p:cNvPr id="17" name="Rounded Rectangle 16"/>
-          <p:cNvSpPr/>
-          <p:nvPr/>
-        </p:nvSpPr>
-        <p:spPr>
-          <a:xfrm>
-            <a:off x="8046720" y="2103120"/>
-            <a:ext cx="3383280" cy="3840480"/>
-          </a:xfrm>
-          <a:prstGeom prst="roundRect">
-            <a:avLst>
-              <a:gd name="adj" fmla="val 5000"/>
-            </a:avLst>
-          </a:prstGeom>
-          <a:solidFill>
-            <a:srgbClr val="1E293B"/>
-          </a:solidFill>
-          <a:ln>
-            <a:noFill/>
-          </a:ln>
-          <a:effectLst/>
-        </p:spPr>
-        <p:style>
-          <a:lnRef idx="1">
-            <a:schemeClr val="accent1"/>
-          </a:lnRef>
-          <a:fillRef idx="3">
-            <a:schemeClr val="accent1"/>
-          </a:fillRef>
-          <a:effectRef idx="2">
-            <a:schemeClr val="accent1"/>
-          </a:effectRef>
-          <a:fontRef idx="minor">
-            <a:schemeClr val="lt1"/>
-          </a:fontRef>
-        </p:style>
-        <p:txBody>
-          <a:bodyPr rtlCol="0" anchor="ctr"/>
-          <a:lstStyle/>
-          <a:p>
-            <a:pPr algn="ctr"/>
-          </a:p>
-        </p:txBody>
-      </p:sp>
-      <p:sp>
-        <p:nvSpPr>
-          <p:cNvPr id="18" name="Rectangle 17"/>
-          <p:cNvSpPr/>
-          <p:nvPr/>
-        </p:nvSpPr>
-        <p:spPr>
-          <a:xfrm>
-            <a:off x="8046720" y="2103120"/>
-            <a:ext cx="3383280" cy="50800"/>
-          </a:xfrm>
-          <a:prstGeom prst="rect">
-            <a:avLst/>
-          </a:prstGeom>
-          <a:solidFill>
-            <a:srgbClr val="F43F5E"/>
-          </a:solidFill>
-          <a:ln>
-            <a:noFill/>
-          </a:ln>
-        </p:spPr>
-        <p:style>
-          <a:lnRef idx="1">
-            <a:schemeClr val="accent1"/>
-          </a:lnRef>
-          <a:fillRef idx="3">
-            <a:schemeClr val="accent1"/>
-          </a:fillRef>
-          <a:effectRef idx="2">
-            <a:schemeClr val="accent1"/>
-          </a:effectRef>
-          <a:fontRef idx="minor">
-            <a:schemeClr val="lt1"/>
-          </a:fontRef>
-        </p:style>
-        <p:txBody>
-          <a:bodyPr rtlCol="0" anchor="ctr"/>
-          <a:lstStyle/>
-          <a:p>
-            <a:pPr algn="ctr"/>
-          </a:p>
-        </p:txBody>
-      </p:sp>
-      <p:sp>
-        <p:nvSpPr>
-          <p:cNvPr id="19" name="TextBox 18"/>
-          <p:cNvSpPr txBox="1"/>
-          <p:nvPr/>
-        </p:nvSpPr>
-        <p:spPr>
-          <a:xfrm>
-            <a:off x="8321040" y="2377440"/>
-            <a:ext cx="2834640" cy="365760"/>
-          </a:xfrm>
-          <a:prstGeom prst="rect">
-            <a:avLst/>
-          </a:prstGeom>
-          <a:noFill/>
-        </p:spPr>
-        <p:txBody>
-          <a:bodyPr wrap="square">
-            <a:spAutoFit/>
-          </a:bodyPr>
-          <a:lstStyle/>
-          <a:p>
-            <a:pPr algn="l">
-              <a:defRPr sz="2000" b="1">
-                <a:solidFill>
-                  <a:srgbClr val="F8FAFC"/>
-                </a:solidFill>
-                <a:latin typeface="Calibri"/>
-              </a:defRPr>
-            </a:pPr>
-            <a:r>
-              <a:t>輸出節點 (output)</a:t>
-            </a:r>
-          </a:p>
-        </p:txBody>
-      </p:sp>
-      <p:sp>
-        <p:nvSpPr>
-          <p:cNvPr id="20" name="TextBox 19"/>
-          <p:cNvSpPr txBox="1"/>
-          <p:nvPr/>
-        </p:nvSpPr>
-        <p:spPr>
-          <a:xfrm>
-            <a:off x="8321040" y="2834640"/>
-            <a:ext cx="2834640" cy="274320"/>
-          </a:xfrm>
-          <a:prstGeom prst="rect">
-            <a:avLst/>
-          </a:prstGeom>
-          <a:noFill/>
-        </p:spPr>
-        <p:txBody>
-          <a:bodyPr wrap="square">
-            <a:spAutoFit/>
-          </a:bodyPr>
-          <a:lstStyle/>
-          <a:p>
-            <a:pPr algn="l">
-              <a:defRPr sz="1400" b="1">
-                <a:solidFill>
-                  <a:srgbClr val="F43F5E"/>
-                </a:solidFill>
-                <a:latin typeface="Calibri"/>
-              </a:defRPr>
-            </a:pPr>
-            <a:r>
-              <a:t>僅有 target 輸入點</a:t>
-            </a:r>
-          </a:p>
-        </p:txBody>
-      </p:sp>
-      <p:sp>
-        <p:nvSpPr>
-          <p:cNvPr id="21" name="Rectangle 20"/>
-          <p:cNvSpPr/>
-          <p:nvPr/>
-        </p:nvSpPr>
-        <p:spPr>
-          <a:xfrm>
-            <a:off x="8321040" y="3200400"/>
-            <a:ext cx="548640" cy="38100"/>
-          </a:xfrm>
-          <a:prstGeom prst="rect">
-            <a:avLst/>
-          </a:prstGeom>
-          <a:solidFill>
-            <a:srgbClr val="F43F5E"/>
-          </a:solidFill>
-          <a:ln>
-            <a:noFill/>
-          </a:ln>
-        </p:spPr>
-        <p:style>
-          <a:lnRef idx="1">
-            <a:schemeClr val="accent1"/>
-          </a:lnRef>
-          <a:fillRef idx="3">
-            <a:schemeClr val="accent1"/>
-          </a:fillRef>
-          <a:effectRef idx="2">
-            <a:schemeClr val="accent1"/>
-          </a:effectRef>
-          <a:fontRef idx="minor">
-            <a:schemeClr val="lt1"/>
-          </a:fontRef>
-        </p:style>
-        <p:txBody>
-          <a:bodyPr rtlCol="0" anchor="ctr"/>
-          <a:lstStyle/>
-          <a:p>
-            <a:pPr algn="ctr"/>
-          </a:p>
-        </p:txBody>
-      </p:sp>
-      <p:sp>
-        <p:nvSpPr>
-          <p:cNvPr id="22" name="TextBox 21"/>
-          <p:cNvSpPr txBox="1"/>
-          <p:nvPr/>
-        </p:nvSpPr>
-        <p:spPr>
-          <a:xfrm>
-            <a:off x="8321040" y="3383280"/>
-            <a:ext cx="2834640" cy="1828800"/>
-          </a:xfrm>
-          <a:prstGeom prst="rect">
-            <a:avLst/>
-          </a:prstGeom>
-          <a:noFill/>
-        </p:spPr>
-        <p:txBody>
-          <a:bodyPr wrap="square">
-            <a:spAutoFit/>
-          </a:bodyPr>
-          <a:lstStyle/>
-          <a:p>
-            <a:pPr algn="l">
-              <a:defRPr sz="1400" b="0">
-                <a:solidFill>
-                  <a:srgbClr val="94A3B8"/>
-                </a:solidFill>
-                <a:latin typeface="Calibri"/>
-              </a:defRPr>
-            </a:pPr>
-            <a:r>
-              <a:t>一般用於流程圖的終點，例如「寫入資料庫」或「結束」。</a:t>
-            </a:r>
-          </a:p>
-        </p:txBody>
-      </p:sp>
-    </p:spTree>
-  </p:cSld>
-  <p:clrMapOvr>
-    <a:masterClrMapping/>
-  </p:clrMapOvr>
-</p:sld>
-</file>
-
-<file path=ppt/slides/slide4.xml><?xml version="1.0" encoding="utf-8"?>
-<p:sld xmlns:a="http://schemas.openxmlformats.org/drawingml/2006/main" xmlns:p="http://schemas.openxmlformats.org/presentationml/2006/main" xmlns:r="http://schemas.openxmlformats.org/officeDocument/2006/relationships">
-  <p:cSld>
-    <p:bg>
-      <p:bgPr>
-        <a:solidFill>
-          <a:srgbClr val="0F172A"/>
-        </a:solidFill>
-        <a:effectLst/>
-      </p:bgPr>
-    </p:bg>
-    <p:spTree>
-      <p:nvGrpSpPr>
-        <p:cNvPr id="1" name=""/>
-        <p:cNvGrpSpPr/>
-        <p:nvPr/>
-      </p:nvGrpSpPr>
-      <p:grpSpPr/>
-      <p:sp>
-        <p:nvSpPr>
-          <p:cNvPr id="2" name="TextBox 1"/>
-          <p:cNvSpPr txBox="1"/>
-          <p:nvPr/>
-        </p:nvSpPr>
-        <p:spPr>
-          <a:xfrm>
-            <a:off x="731520" y="457200"/>
-            <a:ext cx="4572000" cy="365760"/>
-          </a:xfrm>
-          <a:prstGeom prst="rect">
-            <a:avLst/>
-          </a:prstGeom>
-          <a:noFill/>
-        </p:spPr>
-        <p:txBody>
-          <a:bodyPr wrap="square">
-            <a:spAutoFit/>
-          </a:bodyPr>
-          <a:lstStyle/>
-          <a:p>
-            <a:pPr algn="l">
-              <a:defRPr sz="1300" b="1">
-                <a:solidFill>
-                  <a:srgbClr val="10B981"/>
-                </a:solidFill>
-                <a:latin typeface="Calibri"/>
-              </a:defRPr>
-            </a:pPr>
-            <a:r>
-              <a:t>03  QUICK INTEGRATION</a:t>
-            </a:r>
-          </a:p>
-        </p:txBody>
-      </p:sp>
-      <p:sp>
-        <p:nvSpPr>
-          <p:cNvPr id="3" name="TextBox 2"/>
-          <p:cNvSpPr txBox="1"/>
-          <p:nvPr/>
-        </p:nvSpPr>
-        <p:spPr>
-          <a:xfrm>
-            <a:off x="731520" y="914400"/>
-            <a:ext cx="10058400" cy="731520"/>
-          </a:xfrm>
-          <a:prstGeom prst="rect">
-            <a:avLst/>
-          </a:prstGeom>
-          <a:noFill/>
-        </p:spPr>
-        <p:txBody>
-          <a:bodyPr wrap="square">
-            <a:spAutoFit/>
-          </a:bodyPr>
-          <a:lstStyle/>
-          <a:p>
-            <a:pPr algn="l">
-              <a:defRPr sz="3200" b="1">
-                <a:solidFill>
-                  <a:srgbClr val="F8FAFC"/>
-                </a:solidFill>
-                <a:latin typeface="Calibri"/>
-              </a:defRPr>
-            </a:pPr>
-            <a:r>
-              <a:t>環境配置與快速啟用</a:t>
-            </a:r>
-          </a:p>
-        </p:txBody>
-      </p:sp>
-      <p:sp>
-        <p:nvSpPr>
-          <p:cNvPr id="4" name="Rectangle 3"/>
-          <p:cNvSpPr/>
-          <p:nvPr/>
-        </p:nvSpPr>
-        <p:spPr>
-          <a:xfrm>
-            <a:off x="731520" y="1645920"/>
-            <a:ext cx="1097280" cy="38100"/>
-          </a:xfrm>
-          <a:prstGeom prst="rect">
-            <a:avLst/>
-          </a:prstGeom>
-          <a:solidFill>
-            <a:srgbClr val="10B981"/>
-          </a:solidFill>
-          <a:ln>
-            <a:noFill/>
-          </a:ln>
-        </p:spPr>
-        <p:style>
-          <a:lnRef idx="1">
-            <a:schemeClr val="accent1"/>
-          </a:lnRef>
-          <a:fillRef idx="3">
-            <a:schemeClr val="accent1"/>
-          </a:fillRef>
-          <a:effectRef idx="2">
-            <a:schemeClr val="accent1"/>
-          </a:effectRef>
-          <a:fontRef idx="minor">
-            <a:schemeClr val="lt1"/>
-          </a:fontRef>
-        </p:style>
-        <p:txBody>
-          <a:bodyPr rtlCol="0" anchor="ctr"/>
-          <a:lstStyle/>
-          <a:p>
-            <a:pPr algn="ctr"/>
-          </a:p>
-        </p:txBody>
-      </p:sp>
-      <p:sp>
-        <p:nvSpPr>
           <p:cNvPr id="5" name="TextBox 4"/>
           <p:cNvSpPr txBox="1"/>
           <p:nvPr/>
@@ -4811,10 +4123,10 @@
           <a:p>
             <a:pPr>
               <a:spcBef>
-                <a:spcPts val="600"/>
-              </a:spcBef>
-              <a:spcAft>
-                <a:spcPts val="400"/>
+                <a:spcPts val="500"/>
+              </a:spcBef>
+              <a:spcAft>
+                <a:spcPts val="300"/>
               </a:spcAft>
             </a:pPr>
             <a:r>
@@ -4845,10 +4157,10 @@
           <a:p>
             <a:pPr>
               <a:spcBef>
-                <a:spcPts val="600"/>
-              </a:spcBef>
-              <a:spcAft>
-                <a:spcPts val="400"/>
+                <a:spcPts val="500"/>
+              </a:spcBef>
+              <a:spcAft>
+                <a:spcPts val="300"/>
               </a:spcAft>
             </a:pPr>
             <a:r>
@@ -4865,6 +4177,40 @@
                   <a:srgbClr val="F8FAFC"/>
                 </a:solidFill>
               </a:rPr>
+              <a:t>畫布容器</a:t>
+            </a:r>
+            <a:r>
+              <a:rPr sz="1350">
+                <a:solidFill>
+                  <a:srgbClr val="94A3B8"/>
+                </a:solidFill>
+              </a:rPr>
+              <a:t>  —  外層 DOM 容器必須被給予明確的高度 (如 100vh)，否則 Vue Flow 內部無法完成定位計算。</a:t>
+            </a:r>
+          </a:p>
+          <a:p>
+            <a:pPr>
+              <a:spcBef>
+                <a:spcPts val="500"/>
+              </a:spcBef>
+              <a:spcAft>
+                <a:spcPts val="300"/>
+              </a:spcAft>
+            </a:pPr>
+            <a:r>
+              <a:rPr sz="1500">
+                <a:solidFill>
+                  <a:srgbClr val="10B981"/>
+                </a:solidFill>
+              </a:rPr>
+              <a:t>3️⃣  </a:t>
+            </a:r>
+            <a:r>
+              <a:rPr sz="1500" b="1">
+                <a:solidFill>
+                  <a:srgbClr val="F8FAFC"/>
+                </a:solidFill>
+              </a:rPr>
               <a:t>樣式載入</a:t>
             </a:r>
             <a:r>
@@ -4873,41 +4219,7 @@
                   <a:srgbClr val="94A3B8"/>
                 </a:solidFill>
               </a:rPr>
-              <a:t>  —  在 main.ts 引入官方 CSS 與主題，以及自訂的覆寫樣式 (以本專案 style.css 為主)</a:t>
-            </a:r>
-          </a:p>
-          <a:p>
-            <a:pPr>
-              <a:spcBef>
-                <a:spcPts val="600"/>
-              </a:spcBef>
-              <a:spcAft>
-                <a:spcPts val="400"/>
-              </a:spcAft>
-            </a:pPr>
-            <a:r>
-              <a:rPr sz="1500">
-                <a:solidFill>
-                  <a:srgbClr val="10B981"/>
-                </a:solidFill>
-              </a:rPr>
-              <a:t>3️⃣  </a:t>
-            </a:r>
-            <a:r>
-              <a:rPr sz="1500" b="1">
-                <a:solidFill>
-                  <a:srgbClr val="F8FAFC"/>
-                </a:solidFill>
-              </a:rPr>
-              <a:t>畫布容器</a:t>
-            </a:r>
-            <a:r>
-              <a:rPr sz="1350">
-                <a:solidFill>
-                  <a:srgbClr val="94A3B8"/>
-                </a:solidFill>
-              </a:rPr>
-              <a:t>  —  在 App.vue 宣告一個佔滿螢幕或指定高寬的 DOM 容器，然後載入 &lt;VueFlow&gt;</a:t>
+              <a:t>  —  必須匯入官方提供的 core 與 theme 基礎 CSS 樣式，才能使連接孔與邊線正常定位與呈現。</a:t>
             </a:r>
           </a:p>
         </p:txBody>
@@ -4982,7 +4294,7 @@
           <a:p>
             <a:pPr>
               <a:lnSpc>
-                <a:spcPts val="1500"/>
+                <a:spcPts val="1400"/>
               </a:lnSpc>
               <a:spcBef>
                 <a:spcPts val="0"/>
@@ -4992,7 +4304,7 @@
               </a:spcAft>
             </a:pPr>
             <a:r>
-              <a:rPr sz="1000">
+              <a:rPr sz="950">
                 <a:solidFill>
                   <a:srgbClr val="64748B"/>
                 </a:solidFill>
@@ -5004,7 +4316,7 @@
           <a:p>
             <a:pPr>
               <a:lnSpc>
-                <a:spcPts val="1500"/>
+                <a:spcPts val="1400"/>
               </a:lnSpc>
               <a:spcBef>
                 <a:spcPts val="0"/>
@@ -5014,7 +4326,7 @@
               </a:spcAft>
             </a:pPr>
             <a:r>
-              <a:rPr sz="1000">
+              <a:rPr sz="950">
                 <a:solidFill>
                   <a:srgbClr val="C084FC"/>
                 </a:solidFill>
@@ -5023,7 +4335,7 @@
               <a:t>import</a:t>
             </a:r>
             <a:r>
-              <a:rPr sz="1000">
+              <a:rPr sz="950">
                 <a:solidFill>
                   <a:srgbClr val="D4D4D8"/>
                 </a:solidFill>
@@ -5032,7 +4344,7 @@
               <a:t> </a:t>
             </a:r>
             <a:r>
-              <a:rPr sz="1000">
+              <a:rPr sz="950">
                 <a:solidFill>
                   <a:srgbClr val="D4D4D8"/>
                 </a:solidFill>
@@ -5041,7 +4353,7 @@
               <a:t>{</a:t>
             </a:r>
             <a:r>
-              <a:rPr sz="1000">
+              <a:rPr sz="950">
                 <a:solidFill>
                   <a:srgbClr val="D4D4D8"/>
                 </a:solidFill>
@@ -5050,7 +4362,7 @@
               <a:t> createApp </a:t>
             </a:r>
             <a:r>
-              <a:rPr sz="1000">
+              <a:rPr sz="950">
                 <a:solidFill>
                   <a:srgbClr val="D4D4D8"/>
                 </a:solidFill>
@@ -5059,7 +4371,7 @@
               <a:t>}</a:t>
             </a:r>
             <a:r>
-              <a:rPr sz="1000">
+              <a:rPr sz="950">
                 <a:solidFill>
                   <a:srgbClr val="C084FC"/>
                 </a:solidFill>
@@ -5068,7 +4380,7 @@
               <a:t> from</a:t>
             </a:r>
             <a:r>
-              <a:rPr sz="1000">
+              <a:rPr sz="950">
                 <a:solidFill>
                   <a:srgbClr val="D4D4D8"/>
                 </a:solidFill>
@@ -5077,7 +4389,7 @@
               <a:t> </a:t>
             </a:r>
             <a:r>
-              <a:rPr sz="1000">
+              <a:rPr sz="950">
                 <a:solidFill>
                   <a:srgbClr val="34D399"/>
                 </a:solidFill>
@@ -5089,7 +4401,7 @@
           <a:p>
             <a:pPr>
               <a:lnSpc>
-                <a:spcPts val="1500"/>
+                <a:spcPts val="1400"/>
               </a:lnSpc>
               <a:spcBef>
                 <a:spcPts val="0"/>
@@ -5099,7 +4411,7 @@
               </a:spcAft>
             </a:pPr>
             <a:r>
-              <a:rPr sz="1000">
+              <a:rPr sz="950">
                 <a:solidFill>
                   <a:srgbClr val="C084FC"/>
                 </a:solidFill>
@@ -5108,7 +4420,7 @@
               <a:t>import</a:t>
             </a:r>
             <a:r>
-              <a:rPr sz="1000">
+              <a:rPr sz="950">
                 <a:solidFill>
                   <a:srgbClr val="D4D4D8"/>
                 </a:solidFill>
@@ -5117,7 +4429,7 @@
               <a:t> App from </a:t>
             </a:r>
             <a:r>
-              <a:rPr sz="1000">
+              <a:rPr sz="950">
                 <a:solidFill>
                   <a:srgbClr val="34D399"/>
                 </a:solidFill>
@@ -5129,7 +4441,7 @@
           <a:p>
             <a:pPr>
               <a:lnSpc>
-                <a:spcPts val="1500"/>
+                <a:spcPts val="1400"/>
               </a:lnSpc>
               <a:spcBef>
                 <a:spcPts val="0"/>
@@ -5139,7 +4451,7 @@
               </a:spcAft>
             </a:pPr>
             <a:r>
-              <a:rPr sz="1000">
+              <a:rPr sz="950">
                 <a:solidFill>
                   <a:srgbClr val="D4D4D8"/>
                 </a:solidFill>
@@ -5151,7 +4463,7 @@
           <a:p>
             <a:pPr>
               <a:lnSpc>
-                <a:spcPts val="1500"/>
+                <a:spcPts val="1400"/>
               </a:lnSpc>
               <a:spcBef>
                 <a:spcPts val="0"/>
@@ -5161,19 +4473,19 @@
               </a:spcAft>
             </a:pPr>
             <a:r>
-              <a:rPr sz="1000">
+              <a:rPr sz="950">
                 <a:solidFill>
                   <a:srgbClr val="64748B"/>
                 </a:solidFill>
                 <a:latin typeface="Consolas"/>
               </a:rPr>
-              <a:t>/* 1. 核心樣式 */</a:t>
+              <a:t>/* 1. 載入 Vue Flow 核心與外掛 CSS 樣式 */</a:t>
             </a:r>
           </a:p>
           <a:p>
             <a:pPr>
               <a:lnSpc>
-                <a:spcPts val="1500"/>
+                <a:spcPts val="1400"/>
               </a:lnSpc>
               <a:spcBef>
                 <a:spcPts val="0"/>
@@ -5183,7 +4495,7 @@
               </a:spcAft>
             </a:pPr>
             <a:r>
-              <a:rPr sz="1000">
+              <a:rPr sz="950">
                 <a:solidFill>
                   <a:srgbClr val="C084FC"/>
                 </a:solidFill>
@@ -5192,7 +4504,7 @@
               <a:t>import</a:t>
             </a:r>
             <a:r>
-              <a:rPr sz="1000">
+              <a:rPr sz="950">
                 <a:solidFill>
                   <a:srgbClr val="D4D4D8"/>
                 </a:solidFill>
@@ -5201,7 +4513,7 @@
               <a:t> </a:t>
             </a:r>
             <a:r>
-              <a:rPr sz="1000">
+              <a:rPr sz="950">
                 <a:solidFill>
                   <a:srgbClr val="34D399"/>
                 </a:solidFill>
@@ -5213,7 +4525,7 @@
           <a:p>
             <a:pPr>
               <a:lnSpc>
-                <a:spcPts val="1500"/>
+                <a:spcPts val="1400"/>
               </a:lnSpc>
               <a:spcBef>
                 <a:spcPts val="0"/>
@@ -5223,19 +4535,161 @@
               </a:spcAft>
             </a:pPr>
             <a:r>
-              <a:rPr sz="1000">
+              <a:rPr sz="950">
+                <a:solidFill>
+                  <a:srgbClr val="C084FC"/>
+                </a:solidFill>
+                <a:latin typeface="Consolas"/>
+              </a:rPr>
+              <a:t>import</a:t>
+            </a:r>
+            <a:r>
+              <a:rPr sz="950">
+                <a:solidFill>
+                  <a:srgbClr val="D4D4D8"/>
+                </a:solidFill>
+                <a:latin typeface="Consolas"/>
+              </a:rPr>
+              <a:t> </a:t>
+            </a:r>
+            <a:r>
+              <a:rPr sz="950">
+                <a:solidFill>
+                  <a:srgbClr val="34D399"/>
+                </a:solidFill>
+                <a:latin typeface="Consolas"/>
+              </a:rPr>
+              <a:t>'@vue-flow/core/dist/theme-default.css'</a:t>
+            </a:r>
+          </a:p>
+          <a:p>
+            <a:pPr>
+              <a:lnSpc>
+                <a:spcPts val="1400"/>
+              </a:lnSpc>
+              <a:spcBef>
+                <a:spcPts val="0"/>
+              </a:spcBef>
+              <a:spcAft>
+                <a:spcPts val="0"/>
+              </a:spcAft>
+            </a:pPr>
+            <a:r>
+              <a:rPr sz="950">
+                <a:solidFill>
+                  <a:srgbClr val="C084FC"/>
+                </a:solidFill>
+                <a:latin typeface="Consolas"/>
+              </a:rPr>
+              <a:t>import</a:t>
+            </a:r>
+            <a:r>
+              <a:rPr sz="950">
+                <a:solidFill>
+                  <a:srgbClr val="D4D4D8"/>
+                </a:solidFill>
+                <a:latin typeface="Consolas"/>
+              </a:rPr>
+              <a:t> </a:t>
+            </a:r>
+            <a:r>
+              <a:rPr sz="950">
+                <a:solidFill>
+                  <a:srgbClr val="34D399"/>
+                </a:solidFill>
+                <a:latin typeface="Consolas"/>
+              </a:rPr>
+              <a:t>'@vue-flow/controls/dist/style.css'</a:t>
+            </a:r>
+          </a:p>
+          <a:p>
+            <a:pPr>
+              <a:lnSpc>
+                <a:spcPts val="1400"/>
+              </a:lnSpc>
+              <a:spcBef>
+                <a:spcPts val="0"/>
+              </a:spcBef>
+              <a:spcAft>
+                <a:spcPts val="0"/>
+              </a:spcAft>
+            </a:pPr>
+            <a:r>
+              <a:rPr sz="950">
+                <a:solidFill>
+                  <a:srgbClr val="C084FC"/>
+                </a:solidFill>
+                <a:latin typeface="Consolas"/>
+              </a:rPr>
+              <a:t>import</a:t>
+            </a:r>
+            <a:r>
+              <a:rPr sz="950">
+                <a:solidFill>
+                  <a:srgbClr val="D4D4D8"/>
+                </a:solidFill>
+                <a:latin typeface="Consolas"/>
+              </a:rPr>
+              <a:t> </a:t>
+            </a:r>
+            <a:r>
+              <a:rPr sz="950">
+                <a:solidFill>
+                  <a:srgbClr val="34D399"/>
+                </a:solidFill>
+                <a:latin typeface="Consolas"/>
+              </a:rPr>
+              <a:t>'@vue-flow/minimap/dist/style.css'</a:t>
+            </a:r>
+          </a:p>
+          <a:p>
+            <a:pPr>
+              <a:lnSpc>
+                <a:spcPts val="1400"/>
+              </a:lnSpc>
+              <a:spcBef>
+                <a:spcPts val="0"/>
+              </a:spcBef>
+              <a:spcAft>
+                <a:spcPts val="0"/>
+              </a:spcAft>
+            </a:pPr>
+            <a:r>
+              <a:rPr sz="950">
+                <a:solidFill>
+                  <a:srgbClr val="D4D4D8"/>
+                </a:solidFill>
+                <a:latin typeface="Consolas"/>
+              </a:rPr>
+              <a:t/>
+            </a:r>
+          </a:p>
+          <a:p>
+            <a:pPr>
+              <a:lnSpc>
+                <a:spcPts val="1400"/>
+              </a:lnSpc>
+              <a:spcBef>
+                <a:spcPts val="0"/>
+              </a:spcBef>
+              <a:spcAft>
+                <a:spcPts val="0"/>
+              </a:spcAft>
+            </a:pPr>
+            <a:r>
+              <a:rPr sz="950">
                 <a:solidFill>
                   <a:srgbClr val="64748B"/>
                 </a:solidFill>
                 <a:latin typeface="Consolas"/>
               </a:rPr>
-              <a:t>/* 2. 外掛樣式 */</a:t>
+              <a:t>/* 2. 導入自訂樣式覆寫 */</a:t>
             </a:r>
           </a:p>
           <a:p>
             <a:pPr>
               <a:lnSpc>
-                <a:spcPts val="1500"/>
+                <a:spcPts val="1400"/>
               </a:lnSpc>
               <a:spcBef>
                 <a:spcPts val="0"/>
@@ -5245,7 +4699,7 @@
               </a:spcAft>
             </a:pPr>
             <a:r>
-              <a:rPr sz="1000">
+              <a:rPr sz="950">
                 <a:solidFill>
                   <a:srgbClr val="C084FC"/>
                 </a:solidFill>
@@ -5254,7 +4708,7 @@
               <a:t>import</a:t>
             </a:r>
             <a:r>
-              <a:rPr sz="1000">
+              <a:rPr sz="950">
                 <a:solidFill>
                   <a:srgbClr val="D4D4D8"/>
                 </a:solidFill>
@@ -5263,19 +4717,19 @@
               <a:t> </a:t>
             </a:r>
             <a:r>
-              <a:rPr sz="1000">
+              <a:rPr sz="950">
                 <a:solidFill>
                   <a:srgbClr val="34D399"/>
                 </a:solidFill>
                 <a:latin typeface="Consolas"/>
               </a:rPr>
-              <a:t>'@vue-flow/core/dist/theme-default.css'</a:t>
+              <a:t>'./style.css'</a:t>
             </a:r>
           </a:p>
           <a:p>
             <a:pPr>
               <a:lnSpc>
-                <a:spcPts val="1500"/>
+                <a:spcPts val="1400"/>
               </a:lnSpc>
               <a:spcBef>
                 <a:spcPts val="0"/>
@@ -5285,211 +4739,47 @@
               </a:spcAft>
             </a:pPr>
             <a:r>
-              <a:rPr sz="1000">
-                <a:solidFill>
-                  <a:srgbClr val="C084FC"/>
-                </a:solidFill>
-                <a:latin typeface="Consolas"/>
-              </a:rPr>
-              <a:t>import</a:t>
-            </a:r>
-            <a:r>
-              <a:rPr sz="1000">
+              <a:rPr sz="950">
                 <a:solidFill>
                   <a:srgbClr val="D4D4D8"/>
                 </a:solidFill>
                 <a:latin typeface="Consolas"/>
               </a:rPr>
-              <a:t> </a:t>
-            </a:r>
-            <a:r>
-              <a:rPr sz="1000">
+              <a:t/>
+            </a:r>
+          </a:p>
+          <a:p>
+            <a:pPr>
+              <a:lnSpc>
+                <a:spcPts val="1400"/>
+              </a:lnSpc>
+              <a:spcBef>
+                <a:spcPts val="0"/>
+              </a:spcBef>
+              <a:spcAft>
+                <a:spcPts val="0"/>
+              </a:spcAft>
+            </a:pPr>
+            <a:r>
+              <a:rPr sz="950">
+                <a:solidFill>
+                  <a:srgbClr val="D4D4D8"/>
+                </a:solidFill>
+                <a:latin typeface="Consolas"/>
+              </a:rPr>
+              <a:t>createApp(App).mount(</a:t>
+            </a:r>
+            <a:r>
+              <a:rPr sz="950">
                 <a:solidFill>
                   <a:srgbClr val="34D399"/>
                 </a:solidFill>
                 <a:latin typeface="Consolas"/>
               </a:rPr>
-              <a:t>'@vue-flow/controls/dist/style.css'</a:t>
-            </a:r>
-          </a:p>
-          <a:p>
-            <a:pPr>
-              <a:lnSpc>
-                <a:spcPts val="1500"/>
-              </a:lnSpc>
-              <a:spcBef>
-                <a:spcPts val="0"/>
-              </a:spcBef>
-              <a:spcAft>
-                <a:spcPts val="0"/>
-              </a:spcAft>
-            </a:pPr>
-            <a:r>
-              <a:rPr sz="1000">
-                <a:solidFill>
-                  <a:srgbClr val="C084FC"/>
-                </a:solidFill>
-                <a:latin typeface="Consolas"/>
-              </a:rPr>
-              <a:t>import</a:t>
-            </a:r>
-            <a:r>
-              <a:rPr sz="1000">
-                <a:solidFill>
-                  <a:srgbClr val="D4D4D8"/>
-                </a:solidFill>
-                <a:latin typeface="Consolas"/>
-              </a:rPr>
-              <a:t> </a:t>
-            </a:r>
-            <a:r>
-              <a:rPr sz="1000">
-                <a:solidFill>
-                  <a:srgbClr val="34D399"/>
-                </a:solidFill>
-                <a:latin typeface="Consolas"/>
-              </a:rPr>
-              <a:t>'@vue-flow/minimap/dist/style.css'</a:t>
-            </a:r>
-          </a:p>
-          <a:p>
-            <a:pPr>
-              <a:lnSpc>
-                <a:spcPts val="1500"/>
-              </a:lnSpc>
-              <a:spcBef>
-                <a:spcPts val="0"/>
-              </a:spcBef>
-              <a:spcAft>
-                <a:spcPts val="0"/>
-              </a:spcAft>
-            </a:pPr>
-            <a:r>
-              <a:rPr sz="1000">
-                <a:solidFill>
-                  <a:srgbClr val="D4D4D8"/>
-                </a:solidFill>
-                <a:latin typeface="Consolas"/>
-              </a:rPr>
-              <a:t/>
-            </a:r>
-          </a:p>
-          <a:p>
-            <a:pPr>
-              <a:lnSpc>
-                <a:spcPts val="1500"/>
-              </a:lnSpc>
-              <a:spcBef>
-                <a:spcPts val="0"/>
-              </a:spcBef>
-              <a:spcAft>
-                <a:spcPts val="0"/>
-              </a:spcAft>
-            </a:pPr>
-            <a:r>
-              <a:rPr sz="1000">
-                <a:solidFill>
-                  <a:srgbClr val="64748B"/>
-                </a:solidFill>
-                <a:latin typeface="Consolas"/>
-              </a:rPr>
-              <a:t>/* 3. 自訂樣式與主題覆寫 */</a:t>
-            </a:r>
-          </a:p>
-          <a:p>
-            <a:pPr>
-              <a:lnSpc>
-                <a:spcPts val="1500"/>
-              </a:lnSpc>
-              <a:spcBef>
-                <a:spcPts val="0"/>
-              </a:spcBef>
-              <a:spcAft>
-                <a:spcPts val="0"/>
-              </a:spcAft>
-            </a:pPr>
-            <a:r>
-              <a:rPr sz="1000">
-                <a:solidFill>
-                  <a:srgbClr val="C084FC"/>
-                </a:solidFill>
-                <a:latin typeface="Consolas"/>
-              </a:rPr>
-              <a:t>import</a:t>
-            </a:r>
-            <a:r>
-              <a:rPr sz="1000">
-                <a:solidFill>
-                  <a:srgbClr val="D4D4D8"/>
-                </a:solidFill>
-                <a:latin typeface="Consolas"/>
-              </a:rPr>
-              <a:t> </a:t>
-            </a:r>
-            <a:r>
-              <a:rPr sz="1000">
-                <a:solidFill>
-                  <a:srgbClr val="34D399"/>
-                </a:solidFill>
-                <a:latin typeface="Consolas"/>
-              </a:rPr>
-              <a:t>'./style.css'</a:t>
-            </a:r>
-          </a:p>
-          <a:p>
-            <a:pPr>
-              <a:lnSpc>
-                <a:spcPts val="1500"/>
-              </a:lnSpc>
-              <a:spcBef>
-                <a:spcPts val="0"/>
-              </a:spcBef>
-              <a:spcAft>
-                <a:spcPts val="0"/>
-              </a:spcAft>
-            </a:pPr>
-            <a:r>
-              <a:rPr sz="1000">
-                <a:solidFill>
-                  <a:srgbClr val="D4D4D8"/>
-                </a:solidFill>
-                <a:latin typeface="Consolas"/>
-              </a:rPr>
-              <a:t/>
-            </a:r>
-          </a:p>
-          <a:p>
-            <a:pPr>
-              <a:lnSpc>
-                <a:spcPts val="1500"/>
-              </a:lnSpc>
-              <a:spcBef>
-                <a:spcPts val="0"/>
-              </a:spcBef>
-              <a:spcAft>
-                <a:spcPts val="0"/>
-              </a:spcAft>
-            </a:pPr>
-            <a:r>
-              <a:rPr sz="1000">
-                <a:solidFill>
-                  <a:srgbClr val="D4D4D8"/>
-                </a:solidFill>
-                <a:latin typeface="Consolas"/>
-              </a:rPr>
-              <a:t>createApp(App).mount(</a:t>
-            </a:r>
-            <a:r>
-              <a:rPr sz="1000">
-                <a:solidFill>
-                  <a:srgbClr val="34D399"/>
-                </a:solidFill>
-                <a:latin typeface="Consolas"/>
-              </a:rPr>
               <a:t>'#app'</a:t>
             </a:r>
             <a:r>
-              <a:rPr sz="1000">
+              <a:rPr sz="950">
                 <a:solidFill>
                   <a:srgbClr val="D4D4D8"/>
                 </a:solidFill>
@@ -5508,7 +4798,7 @@
 </p:sld>
 </file>
 
-<file path=ppt/slides/slide5.xml><?xml version="1.0" encoding="utf-8"?>
+<file path=ppt/slides/slide4.xml><?xml version="1.0" encoding="utf-8"?>
 <p:sld xmlns:a="http://schemas.openxmlformats.org/drawingml/2006/main" xmlns:p="http://schemas.openxmlformats.org/presentationml/2006/main" xmlns:r="http://schemas.openxmlformats.org/officeDocument/2006/relationships">
   <p:cSld>
     <p:bg>
@@ -5557,7 +4847,7 @@
               </a:defRPr>
             </a:pPr>
             <a:r>
-              <a:t>04  CODE EXAMPLES</a:t>
+              <a:t>03  CUSTOM NODES</a:t>
             </a:r>
           </a:p>
         </p:txBody>
@@ -5593,7 +4883,7 @@
               </a:defRPr>
             </a:pPr>
             <a:r>
-              <a:t>極簡版 App.vue 實作</a:t>
+              <a:t>編寫 SimpleCustomNode 元件</a:t>
             </a:r>
           </a:p>
         </p:txBody>
@@ -5711,7 +5001,7 @@
           <a:p>
             <a:pPr>
               <a:lnSpc>
-                <a:spcPts val="1500"/>
+                <a:spcPts val="1400"/>
               </a:lnSpc>
               <a:spcBef>
                 <a:spcPts val="0"/>
@@ -5721,7 +5011,29 @@
               </a:spcAft>
             </a:pPr>
             <a:r>
-              <a:rPr sz="1000">
+              <a:rPr sz="950">
+                <a:solidFill>
+                  <a:srgbClr val="64748B"/>
+                </a:solidFill>
+                <a:latin typeface="Consolas"/>
+              </a:rPr>
+              <a:t>&lt;!-- SimpleCustomNode.vue --&gt;</a:t>
+            </a:r>
+          </a:p>
+          <a:p>
+            <a:pPr>
+              <a:lnSpc>
+                <a:spcPts val="1400"/>
+              </a:lnSpc>
+              <a:spcBef>
+                <a:spcPts val="0"/>
+              </a:spcBef>
+              <a:spcAft>
+                <a:spcPts val="0"/>
+              </a:spcAft>
+            </a:pPr>
+            <a:r>
+              <a:rPr sz="950">
                 <a:solidFill>
                   <a:srgbClr val="FB7185"/>
                 </a:solidFill>
@@ -5733,7 +5045,7 @@
           <a:p>
             <a:pPr>
               <a:lnSpc>
-                <a:spcPts val="1500"/>
+                <a:spcPts val="1400"/>
               </a:lnSpc>
               <a:spcBef>
                 <a:spcPts val="0"/>
@@ -5743,7 +5055,7 @@
               </a:spcAft>
             </a:pPr>
             <a:r>
-              <a:rPr sz="1000">
+              <a:rPr sz="950">
                 <a:solidFill>
                   <a:srgbClr val="C084FC"/>
                 </a:solidFill>
@@ -5752,28 +5064,28 @@
               <a:t>import</a:t>
             </a:r>
             <a:r>
-              <a:rPr sz="1000">
+              <a:rPr sz="950">
                 <a:solidFill>
                   <a:srgbClr val="D4D4D8"/>
                 </a:solidFill>
                 <a:latin typeface="Consolas"/>
               </a:rPr>
-              <a:t> { ref } from </a:t>
-            </a:r>
-            <a:r>
-              <a:rPr sz="1000">
+              <a:t> { Handle, Position } from </a:t>
+            </a:r>
+            <a:r>
+              <a:rPr sz="950">
                 <a:solidFill>
                   <a:srgbClr val="34D399"/>
                 </a:solidFill>
                 <a:latin typeface="Consolas"/>
               </a:rPr>
-              <a:t>'vue'</a:t>
+              <a:t>'@vue-flow/core'</a:t>
             </a:r>
           </a:p>
           <a:p>
             <a:pPr>
               <a:lnSpc>
-                <a:spcPts val="1500"/>
+                <a:spcPts val="1400"/>
               </a:lnSpc>
               <a:spcBef>
                 <a:spcPts val="0"/>
@@ -5783,37 +5095,143 @@
               </a:spcAft>
             </a:pPr>
             <a:r>
-              <a:rPr sz="1000">
-                <a:solidFill>
-                  <a:srgbClr val="C084FC"/>
-                </a:solidFill>
-                <a:latin typeface="Consolas"/>
-              </a:rPr>
-              <a:t>import</a:t>
-            </a:r>
-            <a:r>
-              <a:rPr sz="1000">
+              <a:rPr sz="950">
                 <a:solidFill>
                   <a:srgbClr val="D4D4D8"/>
                 </a:solidFill>
                 <a:latin typeface="Consolas"/>
               </a:rPr>
-              <a:t> { VueFlow } from </a:t>
-            </a:r>
-            <a:r>
-              <a:rPr sz="1000">
+              <a:t>defineProps&lt;{ data: { emoji: string; title: string; desc: string } }&gt;()</a:t>
+            </a:r>
+          </a:p>
+          <a:p>
+            <a:pPr>
+              <a:lnSpc>
+                <a:spcPts val="1400"/>
+              </a:lnSpc>
+              <a:spcBef>
+                <a:spcPts val="0"/>
+              </a:spcBef>
+              <a:spcAft>
+                <a:spcPts val="0"/>
+              </a:spcAft>
+            </a:pPr>
+            <a:r>
+              <a:rPr sz="950">
+                <a:solidFill>
+                  <a:srgbClr val="FB7185"/>
+                </a:solidFill>
+                <a:latin typeface="Consolas"/>
+              </a:rPr>
+              <a:t>&lt;/script&gt;</a:t>
+            </a:r>
+          </a:p>
+          <a:p>
+            <a:pPr>
+              <a:lnSpc>
+                <a:spcPts val="1400"/>
+              </a:lnSpc>
+              <a:spcBef>
+                <a:spcPts val="0"/>
+              </a:spcBef>
+              <a:spcAft>
+                <a:spcPts val="0"/>
+              </a:spcAft>
+            </a:pPr>
+            <a:r>
+              <a:rPr sz="950">
+                <a:solidFill>
+                  <a:srgbClr val="D4D4D8"/>
+                </a:solidFill>
+                <a:latin typeface="Consolas"/>
+              </a:rPr>
+              <a:t/>
+            </a:r>
+          </a:p>
+          <a:p>
+            <a:pPr>
+              <a:lnSpc>
+                <a:spcPts val="1400"/>
+              </a:lnSpc>
+              <a:spcBef>
+                <a:spcPts val="0"/>
+              </a:spcBef>
+              <a:spcAft>
+                <a:spcPts val="0"/>
+              </a:spcAft>
+            </a:pPr>
+            <a:r>
+              <a:rPr sz="950">
+                <a:solidFill>
+                  <a:srgbClr val="FB7185"/>
+                </a:solidFill>
+                <a:latin typeface="Consolas"/>
+              </a:rPr>
+              <a:t>&lt;template&gt;</a:t>
+            </a:r>
+          </a:p>
+          <a:p>
+            <a:pPr>
+              <a:lnSpc>
+                <a:spcPts val="1400"/>
+              </a:lnSpc>
+              <a:spcBef>
+                <a:spcPts val="0"/>
+              </a:spcBef>
+              <a:spcAft>
+                <a:spcPts val="0"/>
+              </a:spcAft>
+            </a:pPr>
+            <a:r>
+              <a:rPr sz="950">
+                <a:solidFill>
+                  <a:srgbClr val="FB7185"/>
+                </a:solidFill>
+                <a:latin typeface="Consolas"/>
+              </a:rPr>
+              <a:t>  &lt;div </a:t>
+            </a:r>
+            <a:r>
+              <a:rPr sz="950">
+                <a:solidFill>
+                  <a:srgbClr val="818CF8"/>
+                </a:solidFill>
+                <a:latin typeface="Consolas"/>
+              </a:rPr>
+              <a:t>class</a:t>
+            </a:r>
+            <a:r>
+              <a:rPr sz="950">
+                <a:solidFill>
+                  <a:srgbClr val="D4D4D8"/>
+                </a:solidFill>
+                <a:latin typeface="Consolas"/>
+              </a:rPr>
+              <a:t>=</a:t>
+            </a:r>
+            <a:r>
+              <a:rPr sz="950">
                 <a:solidFill>
                   <a:srgbClr val="34D399"/>
                 </a:solidFill>
                 <a:latin typeface="Consolas"/>
               </a:rPr>
-              <a:t>'@vue-flow/core'</a:t>
+              <a:t>"custom-card"</a:t>
+            </a:r>
+            <a:r>
+              <a:rPr sz="950">
+                <a:solidFill>
+                  <a:srgbClr val="FB7185"/>
+                </a:solidFill>
+                <a:latin typeface="Consolas"/>
+              </a:rPr>
+              <a:t>&gt;</a:t>
             </a:r>
           </a:p>
           <a:p>
             <a:pPr>
               <a:lnSpc>
-                <a:spcPts val="1500"/>
+                <a:spcPts val="1400"/>
               </a:lnSpc>
               <a:spcBef>
                 <a:spcPts val="0"/>
@@ -5823,37 +5241,113 @@
               </a:spcAft>
             </a:pPr>
             <a:r>
-              <a:rPr sz="1000">
-                <a:solidFill>
-                  <a:srgbClr val="C084FC"/>
-                </a:solidFill>
-                <a:latin typeface="Consolas"/>
-              </a:rPr>
-              <a:t>import</a:t>
-            </a:r>
-            <a:r>
-              <a:rPr sz="1000">
+              <a:rPr sz="950">
+                <a:solidFill>
+                  <a:srgbClr val="64748B"/>
+                </a:solidFill>
+                <a:latin typeface="Consolas"/>
+              </a:rPr>
+              <a:t>    &lt;!-- 輸入點放置於上方 --&gt;</a:t>
+            </a:r>
+          </a:p>
+          <a:p>
+            <a:pPr>
+              <a:lnSpc>
+                <a:spcPts val="1400"/>
+              </a:lnSpc>
+              <a:spcBef>
+                <a:spcPts val="0"/>
+              </a:spcBef>
+              <a:spcAft>
+                <a:spcPts val="0"/>
+              </a:spcAft>
+            </a:pPr>
+            <a:r>
+              <a:rPr sz="950">
+                <a:solidFill>
+                  <a:srgbClr val="FB7185"/>
+                </a:solidFill>
+                <a:latin typeface="Consolas"/>
+              </a:rPr>
+              <a:t>    &lt;Handle </a:t>
+            </a:r>
+            <a:r>
+              <a:rPr sz="950">
+                <a:solidFill>
+                  <a:srgbClr val="818CF8"/>
+                </a:solidFill>
+                <a:latin typeface="Consolas"/>
+              </a:rPr>
+              <a:t>type</a:t>
+            </a:r>
+            <a:r>
+              <a:rPr sz="950">
                 <a:solidFill>
                   <a:srgbClr val="D4D4D8"/>
                 </a:solidFill>
                 <a:latin typeface="Consolas"/>
               </a:rPr>
-              <a:t> { initialNodes, initialEdges } from </a:t>
-            </a:r>
-            <a:r>
-              <a:rPr sz="1000">
+              <a:t>=</a:t>
+            </a:r>
+            <a:r>
+              <a:rPr sz="950">
                 <a:solidFill>
                   <a:srgbClr val="34D399"/>
                 </a:solidFill>
                 <a:latin typeface="Consolas"/>
               </a:rPr>
-              <a:t>'./initial-elements'</a:t>
+              <a:t>"target"</a:t>
+            </a:r>
+            <a:r>
+              <a:rPr sz="950">
+                <a:solidFill>
+                  <a:srgbClr val="D4D4D8"/>
+                </a:solidFill>
+                <a:latin typeface="Consolas"/>
+              </a:rPr>
+              <a:t> </a:t>
+            </a:r>
+            <a:r>
+              <a:rPr sz="950">
+                <a:solidFill>
+                  <a:srgbClr val="818CF8"/>
+                </a:solidFill>
+                <a:latin typeface="Consolas"/>
+              </a:rPr>
+              <a:t>:position</a:t>
+            </a:r>
+            <a:r>
+              <a:rPr sz="950">
+                <a:solidFill>
+                  <a:srgbClr val="D4D4D8"/>
+                </a:solidFill>
+                <a:latin typeface="Consolas"/>
+              </a:rPr>
+              <a:t>=</a:t>
+            </a:r>
+            <a:r>
+              <a:rPr sz="950">
+                <a:solidFill>
+                  <a:srgbClr val="34D399"/>
+                </a:solidFill>
+                <a:latin typeface="Consolas"/>
+              </a:rPr>
+              <a:t>"Position.Top"</a:t>
+            </a:r>
+            <a:r>
+              <a:rPr sz="950">
+                <a:solidFill>
+                  <a:srgbClr val="FB7185"/>
+                </a:solidFill>
+                <a:latin typeface="Consolas"/>
+              </a:rPr>
+              <a:t> /&gt;</a:t>
             </a:r>
           </a:p>
           <a:p>
             <a:pPr>
               <a:lnSpc>
-                <a:spcPts val="1500"/>
+                <a:spcPts val="1400"/>
               </a:lnSpc>
               <a:spcBef>
                 <a:spcPts val="0"/>
@@ -5863,19 +5357,28 @@
               </a:spcAft>
             </a:pPr>
             <a:r>
-              <a:rPr sz="1000">
+              <a:rPr sz="950">
                 <a:solidFill>
                   <a:srgbClr val="D4D4D8"/>
                 </a:solidFill>
                 <a:latin typeface="Consolas"/>
               </a:rPr>
-              <a:t/>
+              <a:t>    </a:t>
+            </a:r>
+            <a:r>
+              <a:rPr sz="950">
+                <a:solidFill>
+                  <a:srgbClr val="FB7185"/>
+                </a:solidFill>
+                <a:latin typeface="Consolas"/>
+              </a:rPr>
+              <a:t>&lt;span class="emoji"&gt;{{ data.emoji }}&lt;/span&gt;</a:t>
             </a:r>
           </a:p>
           <a:p>
             <a:pPr>
               <a:lnSpc>
-                <a:spcPts val="1500"/>
+                <a:spcPts val="1400"/>
               </a:lnSpc>
               <a:spcBef>
                 <a:spcPts val="0"/>
@@ -5885,28 +5388,28 @@
               </a:spcAft>
             </a:pPr>
             <a:r>
-              <a:rPr sz="1000">
-                <a:solidFill>
-                  <a:srgbClr val="C084FC"/>
-                </a:solidFill>
-                <a:latin typeface="Consolas"/>
-              </a:rPr>
-              <a:t>const</a:t>
-            </a:r>
-            <a:r>
-              <a:rPr sz="1000">
+              <a:rPr sz="950">
                 <a:solidFill>
                   <a:srgbClr val="D4D4D8"/>
                 </a:solidFill>
                 <a:latin typeface="Consolas"/>
               </a:rPr>
-              <a:t> nodes = ref(initialNodes)</a:t>
+              <a:t>    </a:t>
+            </a:r>
+            <a:r>
+              <a:rPr sz="950">
+                <a:solidFill>
+                  <a:srgbClr val="FB7185"/>
+                </a:solidFill>
+                <a:latin typeface="Consolas"/>
+              </a:rPr>
+              <a:t>&lt;div class="title"&gt;{{ data.title }}&lt;/div&gt;</a:t>
             </a:r>
           </a:p>
           <a:p>
             <a:pPr>
               <a:lnSpc>
-                <a:spcPts val="1500"/>
+                <a:spcPts val="1400"/>
               </a:lnSpc>
               <a:spcBef>
                 <a:spcPts val="0"/>
@@ -5916,28 +5419,113 @@
               </a:spcAft>
             </a:pPr>
             <a:r>
-              <a:rPr sz="1000">
-                <a:solidFill>
-                  <a:srgbClr val="C084FC"/>
-                </a:solidFill>
-                <a:latin typeface="Consolas"/>
-              </a:rPr>
-              <a:t>const</a:t>
-            </a:r>
-            <a:r>
-              <a:rPr sz="1000">
+              <a:rPr sz="950">
+                <a:solidFill>
+                  <a:srgbClr val="64748B"/>
+                </a:solidFill>
+                <a:latin typeface="Consolas"/>
+              </a:rPr>
+              <a:t>    &lt;!-- 輸出點放置於下方 --&gt;</a:t>
+            </a:r>
+          </a:p>
+          <a:p>
+            <a:pPr>
+              <a:lnSpc>
+                <a:spcPts val="1400"/>
+              </a:lnSpc>
+              <a:spcBef>
+                <a:spcPts val="0"/>
+              </a:spcBef>
+              <a:spcAft>
+                <a:spcPts val="0"/>
+              </a:spcAft>
+            </a:pPr>
+            <a:r>
+              <a:rPr sz="950">
+                <a:solidFill>
+                  <a:srgbClr val="FB7185"/>
+                </a:solidFill>
+                <a:latin typeface="Consolas"/>
+              </a:rPr>
+              <a:t>    &lt;Handle </a:t>
+            </a:r>
+            <a:r>
+              <a:rPr sz="950">
+                <a:solidFill>
+                  <a:srgbClr val="818CF8"/>
+                </a:solidFill>
+                <a:latin typeface="Consolas"/>
+              </a:rPr>
+              <a:t>type</a:t>
+            </a:r>
+            <a:r>
+              <a:rPr sz="950">
                 <a:solidFill>
                   <a:srgbClr val="D4D4D8"/>
                 </a:solidFill>
                 <a:latin typeface="Consolas"/>
               </a:rPr>
-              <a:t> edges = ref(initialEdges)</a:t>
+              <a:t>=</a:t>
+            </a:r>
+            <a:r>
+              <a:rPr sz="950">
+                <a:solidFill>
+                  <a:srgbClr val="34D399"/>
+                </a:solidFill>
+                <a:latin typeface="Consolas"/>
+              </a:rPr>
+              <a:t>"source"</a:t>
+            </a:r>
+            <a:r>
+              <a:rPr sz="950">
+                <a:solidFill>
+                  <a:srgbClr val="D4D4D8"/>
+                </a:solidFill>
+                <a:latin typeface="Consolas"/>
+              </a:rPr>
+              <a:t> </a:t>
+            </a:r>
+            <a:r>
+              <a:rPr sz="950">
+                <a:solidFill>
+                  <a:srgbClr val="818CF8"/>
+                </a:solidFill>
+                <a:latin typeface="Consolas"/>
+              </a:rPr>
+              <a:t>:position</a:t>
+            </a:r>
+            <a:r>
+              <a:rPr sz="950">
+                <a:solidFill>
+                  <a:srgbClr val="D4D4D8"/>
+                </a:solidFill>
+                <a:latin typeface="Consolas"/>
+              </a:rPr>
+              <a:t>=</a:t>
+            </a:r>
+            <a:r>
+              <a:rPr sz="950">
+                <a:solidFill>
+                  <a:srgbClr val="34D399"/>
+                </a:solidFill>
+                <a:latin typeface="Consolas"/>
+              </a:rPr>
+              <a:t>"Position.Bottom"</a:t>
+            </a:r>
+            <a:r>
+              <a:rPr sz="950">
+                <a:solidFill>
+                  <a:srgbClr val="FB7185"/>
+                </a:solidFill>
+                <a:latin typeface="Consolas"/>
+              </a:rPr>
+              <a:t> /&gt;</a:t>
             </a:r>
           </a:p>
           <a:p>
             <a:pPr>
               <a:lnSpc>
-                <a:spcPts val="1500"/>
+                <a:spcPts val="1400"/>
               </a:lnSpc>
               <a:spcBef>
                 <a:spcPts val="0"/>
@@ -5947,19 +5535,19 @@
               </a:spcAft>
             </a:pPr>
             <a:r>
-              <a:rPr sz="1000">
+              <a:rPr sz="950">
                 <a:solidFill>
                   <a:srgbClr val="FB7185"/>
                 </a:solidFill>
                 <a:latin typeface="Consolas"/>
               </a:rPr>
-              <a:t>&lt;/script&gt;</a:t>
+              <a:t>  &lt;/div&gt;</a:t>
             </a:r>
           </a:p>
           <a:p>
             <a:pPr>
               <a:lnSpc>
-                <a:spcPts val="1500"/>
+                <a:spcPts val="1400"/>
               </a:lnSpc>
               <a:spcBef>
                 <a:spcPts val="0"/>
@@ -5969,308 +5557,7 @@
               </a:spcAft>
             </a:pPr>
             <a:r>
-              <a:rPr sz="1000">
-                <a:solidFill>
-                  <a:srgbClr val="D4D4D8"/>
-                </a:solidFill>
-                <a:latin typeface="Consolas"/>
-              </a:rPr>
-              <a:t/>
-            </a:r>
-          </a:p>
-          <a:p>
-            <a:pPr>
-              <a:lnSpc>
-                <a:spcPts val="1500"/>
-              </a:lnSpc>
-              <a:spcBef>
-                <a:spcPts val="0"/>
-              </a:spcBef>
-              <a:spcAft>
-                <a:spcPts val="0"/>
-              </a:spcAft>
-            </a:pPr>
-            <a:r>
-              <a:rPr sz="1000">
-                <a:solidFill>
-                  <a:srgbClr val="FB7185"/>
-                </a:solidFill>
-                <a:latin typeface="Consolas"/>
-              </a:rPr>
-              <a:t>&lt;template&gt;</a:t>
-            </a:r>
-          </a:p>
-          <a:p>
-            <a:pPr>
-              <a:lnSpc>
-                <a:spcPts val="1500"/>
-              </a:lnSpc>
-              <a:spcBef>
-                <a:spcPts val="0"/>
-              </a:spcBef>
-              <a:spcAft>
-                <a:spcPts val="0"/>
-              </a:spcAft>
-            </a:pPr>
-            <a:r>
-              <a:rPr sz="1000">
-                <a:solidFill>
-                  <a:srgbClr val="D4D4D8"/>
-                </a:solidFill>
-                <a:latin typeface="Consolas"/>
-              </a:rPr>
-              <a:t>  </a:t>
-            </a:r>
-            <a:r>
-              <a:rPr sz="1000">
-                <a:solidFill>
-                  <a:srgbClr val="64748B"/>
-                </a:solidFill>
-                <a:latin typeface="Consolas"/>
-              </a:rPr>
-              <a:t>&lt;!-- 容器必須有指定高度 --&gt;</a:t>
-            </a:r>
-          </a:p>
-          <a:p>
-            <a:pPr>
-              <a:lnSpc>
-                <a:spcPts val="1500"/>
-              </a:lnSpc>
-              <a:spcBef>
-                <a:spcPts val="0"/>
-              </a:spcBef>
-              <a:spcAft>
-                <a:spcPts val="0"/>
-              </a:spcAft>
-            </a:pPr>
-            <a:r>
-              <a:rPr sz="1000">
-                <a:solidFill>
-                  <a:srgbClr val="FB7185"/>
-                </a:solidFill>
-                <a:latin typeface="Consolas"/>
-              </a:rPr>
-              <a:t>  &lt;div </a:t>
-            </a:r>
-            <a:r>
-              <a:rPr sz="1000">
-                <a:solidFill>
-                  <a:srgbClr val="818CF8"/>
-                </a:solidFill>
-                <a:latin typeface="Consolas"/>
-              </a:rPr>
-              <a:t>style</a:t>
-            </a:r>
-            <a:r>
-              <a:rPr sz="1000">
-                <a:solidFill>
-                  <a:srgbClr val="D4D4D8"/>
-                </a:solidFill>
-                <a:latin typeface="Consolas"/>
-              </a:rPr>
-              <a:t>=</a:t>
-            </a:r>
-            <a:r>
-              <a:rPr sz="1000">
-                <a:solidFill>
-                  <a:srgbClr val="34D399"/>
-                </a:solidFill>
-                <a:latin typeface="Consolas"/>
-              </a:rPr>
-              <a:t>"height: 100vh"</a:t>
-            </a:r>
-            <a:r>
-              <a:rPr sz="1000">
-                <a:solidFill>
-                  <a:srgbClr val="FB7185"/>
-                </a:solidFill>
-                <a:latin typeface="Consolas"/>
-              </a:rPr>
-              <a:t>&gt;</a:t>
-            </a:r>
-          </a:p>
-          <a:p>
-            <a:pPr>
-              <a:lnSpc>
-                <a:spcPts val="1500"/>
-              </a:lnSpc>
-              <a:spcBef>
-                <a:spcPts val="0"/>
-              </a:spcBef>
-              <a:spcAft>
-                <a:spcPts val="0"/>
-              </a:spcAft>
-            </a:pPr>
-            <a:r>
-              <a:rPr sz="1000">
-                <a:solidFill>
-                  <a:srgbClr val="FB7185"/>
-                </a:solidFill>
-                <a:latin typeface="Consolas"/>
-              </a:rPr>
-              <a:t>    &lt;VueFlow</a:t>
-            </a:r>
-          </a:p>
-          <a:p>
-            <a:pPr>
-              <a:lnSpc>
-                <a:spcPts val="1500"/>
-              </a:lnSpc>
-              <a:spcBef>
-                <a:spcPts val="0"/>
-              </a:spcBef>
-              <a:spcAft>
-                <a:spcPts val="0"/>
-              </a:spcAft>
-            </a:pPr>
-            <a:r>
-              <a:rPr sz="1000">
-                <a:solidFill>
-                  <a:srgbClr val="818CF8"/>
-                </a:solidFill>
-                <a:latin typeface="Consolas"/>
-              </a:rPr>
-              <a:t>      v-model:nodes</a:t>
-            </a:r>
-            <a:r>
-              <a:rPr sz="1000">
-                <a:solidFill>
-                  <a:srgbClr val="D4D4D8"/>
-                </a:solidFill>
-                <a:latin typeface="Consolas"/>
-              </a:rPr>
-              <a:t>=</a:t>
-            </a:r>
-            <a:r>
-              <a:rPr sz="1000">
-                <a:solidFill>
-                  <a:srgbClr val="34D399"/>
-                </a:solidFill>
-                <a:latin typeface="Consolas"/>
-              </a:rPr>
-              <a:t>"nodes"</a:t>
-            </a:r>
-          </a:p>
-          <a:p>
-            <a:pPr>
-              <a:lnSpc>
-                <a:spcPts val="1500"/>
-              </a:lnSpc>
-              <a:spcBef>
-                <a:spcPts val="0"/>
-              </a:spcBef>
-              <a:spcAft>
-                <a:spcPts val="0"/>
-              </a:spcAft>
-            </a:pPr>
-            <a:r>
-              <a:rPr sz="1000">
-                <a:solidFill>
-                  <a:srgbClr val="818CF8"/>
-                </a:solidFill>
-                <a:latin typeface="Consolas"/>
-              </a:rPr>
-              <a:t>      v-model:edges</a:t>
-            </a:r>
-            <a:r>
-              <a:rPr sz="1000">
-                <a:solidFill>
-                  <a:srgbClr val="D4D4D8"/>
-                </a:solidFill>
-                <a:latin typeface="Consolas"/>
-              </a:rPr>
-              <a:t>=</a:t>
-            </a:r>
-            <a:r>
-              <a:rPr sz="1000">
-                <a:solidFill>
-                  <a:srgbClr val="34D399"/>
-                </a:solidFill>
-                <a:latin typeface="Consolas"/>
-              </a:rPr>
-              <a:t>"edges"</a:t>
-            </a:r>
-          </a:p>
-          <a:p>
-            <a:pPr>
-              <a:lnSpc>
-                <a:spcPts val="1500"/>
-              </a:lnSpc>
-              <a:spcBef>
-                <a:spcPts val="0"/>
-              </a:spcBef>
-              <a:spcAft>
-                <a:spcPts val="0"/>
-              </a:spcAft>
-            </a:pPr>
-            <a:r>
-              <a:rPr sz="1000">
-                <a:solidFill>
-                  <a:srgbClr val="818CF8"/>
-                </a:solidFill>
-                <a:latin typeface="Consolas"/>
-              </a:rPr>
-              <a:t>      fit-view-on-init</a:t>
-            </a:r>
-          </a:p>
-          <a:p>
-            <a:pPr>
-              <a:lnSpc>
-                <a:spcPts val="1500"/>
-              </a:lnSpc>
-              <a:spcBef>
-                <a:spcPts val="0"/>
-              </a:spcBef>
-              <a:spcAft>
-                <a:spcPts val="0"/>
-              </a:spcAft>
-            </a:pPr>
-            <a:r>
-              <a:rPr sz="1000">
-                <a:solidFill>
-                  <a:srgbClr val="FB7185"/>
-                </a:solidFill>
-                <a:latin typeface="Consolas"/>
-              </a:rPr>
-              <a:t>    /&gt;</a:t>
-            </a:r>
-          </a:p>
-          <a:p>
-            <a:pPr>
-              <a:lnSpc>
-                <a:spcPts val="1500"/>
-              </a:lnSpc>
-              <a:spcBef>
-                <a:spcPts val="0"/>
-              </a:spcBef>
-              <a:spcAft>
-                <a:spcPts val="0"/>
-              </a:spcAft>
-            </a:pPr>
-            <a:r>
-              <a:rPr sz="1000">
-                <a:solidFill>
-                  <a:srgbClr val="FB7185"/>
-                </a:solidFill>
-                <a:latin typeface="Consolas"/>
-              </a:rPr>
-              <a:t>  &lt;/div&gt;</a:t>
-            </a:r>
-          </a:p>
-          <a:p>
-            <a:pPr>
-              <a:lnSpc>
-                <a:spcPts val="1500"/>
-              </a:lnSpc>
-              <a:spcBef>
-                <a:spcPts val="0"/>
-              </a:spcBef>
-              <a:spcAft>
-                <a:spcPts val="0"/>
-              </a:spcAft>
-            </a:pPr>
-            <a:r>
-              <a:rPr sz="1000">
+              <a:rPr sz="950">
                 <a:solidFill>
                   <a:srgbClr val="FB7185"/>
                 </a:solidFill>
@@ -6305,10 +5592,10 @@
           <a:p>
             <a:pPr>
               <a:spcBef>
-                <a:spcPts val="600"/>
-              </a:spcBef>
-              <a:spcAft>
-                <a:spcPts val="400"/>
+                <a:spcPts val="500"/>
+              </a:spcBef>
+              <a:spcAft>
+                <a:spcPts val="300"/>
               </a:spcAft>
             </a:pPr>
             <a:r>
@@ -6317,7 +5604,7 @@
                   <a:srgbClr val="10B981"/>
                 </a:solidFill>
               </a:rPr>
-              <a:t>📦  </a:t>
+              <a:t>🔵  </a:t>
             </a:r>
             <a:r>
               <a:rPr sz="1500" b="1">
@@ -6325,7 +5612,7 @@
                   <a:srgbClr val="F8FAFC"/>
                 </a:solidFill>
               </a:rPr>
-              <a:t>v-model 響應式雙向綁定</a:t>
+              <a:t>引入 Handle 元件</a:t>
             </a:r>
             <a:r>
               <a:rPr sz="1350">
@@ -6333,16 +5620,16 @@
                   <a:srgbClr val="94A3B8"/>
                 </a:solidFill>
               </a:rPr>
-              <a:t>  —  Vue Flow 將畫面節點位置及狀態同步回 variables。</a:t>
-            </a:r>
-          </a:p>
-          <a:p>
-            <a:pPr>
-              <a:spcBef>
-                <a:spcPts val="600"/>
-              </a:spcBef>
-              <a:spcAft>
-                <a:spcPts val="400"/>
+              <a:t>  —  Handle 是連線的出入口。type 可設定為 target (輸入端) 或 source (輸出端)。</a:t>
+            </a:r>
+          </a:p>
+          <a:p>
+            <a:pPr>
+              <a:spcBef>
+                <a:spcPts val="500"/>
+              </a:spcBef>
+              <a:spcAft>
+                <a:spcPts val="300"/>
               </a:spcAft>
             </a:pPr>
             <a:r>
@@ -6351,7 +5638,7 @@
                   <a:srgbClr val="10B981"/>
                 </a:solidFill>
               </a:rPr>
-              <a:t>📐  </a:t>
+              <a:t>🧭  </a:t>
             </a:r>
             <a:r>
               <a:rPr sz="1500" b="1">
@@ -6359,7 +5646,7 @@
                   <a:srgbClr val="F8FAFC"/>
                 </a:solidFill>
               </a:rPr>
-              <a:t>自動適配畫面 (fitView)</a:t>
+              <a:t>Position 定位設定</a:t>
             </a:r>
             <a:r>
               <a:rPr sz="1350">
@@ -6367,16 +5654,16 @@
                   <a:srgbClr val="94A3B8"/>
                 </a:solidFill>
               </a:rPr>
-              <a:t>  —  啟用 fit-view-on-init 可以讓流程圖在載入時自動置中並調整縮放比例。</a:t>
-            </a:r>
-          </a:p>
-          <a:p>
-            <a:pPr>
-              <a:spcBef>
-                <a:spcPts val="600"/>
-              </a:spcBef>
-              <a:spcAft>
-                <a:spcPts val="400"/>
+              <a:t>  —  藉由 Position.Top, Position.Bottom, Position.Left, Position.Right 來決定連接孔在卡片上的方位。</a:t>
+            </a:r>
+          </a:p>
+          <a:p>
+            <a:pPr>
+              <a:spcBef>
+                <a:spcPts val="500"/>
+              </a:spcBef>
+              <a:spcAft>
+                <a:spcPts val="300"/>
               </a:spcAft>
             </a:pPr>
             <a:r>
@@ -6385,7 +5672,7 @@
                   <a:srgbClr val="10B981"/>
                 </a:solidFill>
               </a:rPr>
-              <a:t>⚡  </a:t>
+              <a:t>🎨  </a:t>
             </a:r>
             <a:r>
               <a:rPr sz="1500" b="1">
@@ -6393,7 +5680,7 @@
                   <a:srgbClr val="F8FAFC"/>
                 </a:solidFill>
               </a:rPr>
-              <a:t>程式碼極度乾淨</a:t>
+              <a:t>高度彈性的客製卡片</a:t>
             </a:r>
             <a:r>
               <a:rPr sz="1350">
@@ -6401,7 +5688,7 @@
                   <a:srgbClr val="94A3B8"/>
                 </a:solidFill>
               </a:rPr>
-              <a:t>  —  不需要手動使用 useVueFlow 或是註冊自訂節點，只需定義基本資料即可跑起來。</a:t>
+              <a:t>  —  在 &lt;template&gt; 中可以編寫任何自訂 HTML，甚至置入表單或交互按鈕，完全取代原生外觀。</a:t>
             </a:r>
           </a:p>
         </p:txBody>
@@ -6414,7 +5701,7 @@
 </p:sld>
 </file>
 
-<file path=ppt/slides/slide6.xml><?xml version="1.0" encoding="utf-8"?>
+<file path=ppt/slides/slide5.xml><?xml version="1.0" encoding="utf-8"?>
 <p:sld xmlns:a="http://schemas.openxmlformats.org/drawingml/2006/main" xmlns:p="http://schemas.openxmlformats.org/presentationml/2006/main" xmlns:r="http://schemas.openxmlformats.org/officeDocument/2006/relationships">
   <p:cSld>
     <p:bg>
@@ -6463,7 +5750,7 @@
               </a:defRPr>
             </a:pPr>
             <a:r>
-              <a:t>05  CONNECTIONS &amp; PLUGINS</a:t>
+              <a:t>04  NODE REGISTRATION</a:t>
             </a:r>
           </a:p>
         </p:txBody>
@@ -6499,7 +5786,7 @@
               </a:defRPr>
             </a:pPr>
             <a:r>
-              <a:t>事件處理與輔助外掛</a:t>
+              <a:t>元件註冊與 markRaw 效能優化</a:t>
             </a:r>
           </a:p>
         </p:txBody>
@@ -6617,7 +5904,7 @@
           <a:p>
             <a:pPr>
               <a:lnSpc>
-                <a:spcPts val="1500"/>
+                <a:spcPts val="1400"/>
               </a:lnSpc>
               <a:spcBef>
                 <a:spcPts val="0"/>
@@ -6627,19 +5914,19 @@
               </a:spcAft>
             </a:pPr>
             <a:r>
-              <a:rPr sz="1000">
+              <a:rPr sz="950">
                 <a:solidFill>
                   <a:srgbClr val="64748B"/>
                 </a:solidFill>
                 <a:latin typeface="Consolas"/>
               </a:rPr>
-              <a:t>/* App.vue - 連線邏輯與外掛整合 */</a:t>
+              <a:t>&lt;!-- App.vue --&gt;</a:t>
             </a:r>
           </a:p>
           <a:p>
             <a:pPr>
               <a:lnSpc>
-                <a:spcPts val="1500"/>
+                <a:spcPts val="1400"/>
               </a:lnSpc>
               <a:spcBef>
                 <a:spcPts val="0"/>
@@ -6649,28 +5936,214 @@
               </a:spcAft>
             </a:pPr>
             <a:r>
-              <a:rPr sz="1000">
+              <a:rPr sz="950">
+                <a:solidFill>
+                  <a:srgbClr val="FB7185"/>
+                </a:solidFill>
+                <a:latin typeface="Consolas"/>
+              </a:rPr>
+              <a:t>&lt;script setup lang="ts"&gt;</a:t>
+            </a:r>
+          </a:p>
+          <a:p>
+            <a:pPr>
+              <a:lnSpc>
+                <a:spcPts val="1400"/>
+              </a:lnSpc>
+              <a:spcBef>
+                <a:spcPts val="0"/>
+              </a:spcBef>
+              <a:spcAft>
+                <a:spcPts val="0"/>
+              </a:spcAft>
+            </a:pPr>
+            <a:r>
+              <a:rPr sz="950">
                 <a:solidFill>
                   <a:srgbClr val="C084FC"/>
                 </a:solidFill>
                 <a:latin typeface="Consolas"/>
               </a:rPr>
+              <a:t>import</a:t>
+            </a:r>
+            <a:r>
+              <a:rPr sz="950">
+                <a:solidFill>
+                  <a:srgbClr val="D4D4D8"/>
+                </a:solidFill>
+                <a:latin typeface="Consolas"/>
+              </a:rPr>
+              <a:t> { ref, markRaw } from </a:t>
+            </a:r>
+            <a:r>
+              <a:rPr sz="950">
+                <a:solidFill>
+                  <a:srgbClr val="34D399"/>
+                </a:solidFill>
+                <a:latin typeface="Consolas"/>
+              </a:rPr>
+              <a:t>'vue'</a:t>
+            </a:r>
+          </a:p>
+          <a:p>
+            <a:pPr>
+              <a:lnSpc>
+                <a:spcPts val="1400"/>
+              </a:lnSpc>
+              <a:spcBef>
+                <a:spcPts val="0"/>
+              </a:spcBef>
+              <a:spcAft>
+                <a:spcPts val="0"/>
+              </a:spcAft>
+            </a:pPr>
+            <a:r>
+              <a:rPr sz="950">
+                <a:solidFill>
+                  <a:srgbClr val="C084FC"/>
+                </a:solidFill>
+                <a:latin typeface="Consolas"/>
+              </a:rPr>
+              <a:t>import</a:t>
+            </a:r>
+            <a:r>
+              <a:rPr sz="950">
+                <a:solidFill>
+                  <a:srgbClr val="D4D4D8"/>
+                </a:solidFill>
+                <a:latin typeface="Consolas"/>
+              </a:rPr>
+              <a:t> { VueFlow } from </a:t>
+            </a:r>
+            <a:r>
+              <a:rPr sz="950">
+                <a:solidFill>
+                  <a:srgbClr val="34D399"/>
+                </a:solidFill>
+                <a:latin typeface="Consolas"/>
+              </a:rPr>
+              <a:t>'@vue-flow/core'</a:t>
+            </a:r>
+          </a:p>
+          <a:p>
+            <a:pPr>
+              <a:lnSpc>
+                <a:spcPts val="1400"/>
+              </a:lnSpc>
+              <a:spcBef>
+                <a:spcPts val="0"/>
+              </a:spcBef>
+              <a:spcAft>
+                <a:spcPts val="0"/>
+              </a:spcAft>
+            </a:pPr>
+            <a:r>
+              <a:rPr sz="950">
+                <a:solidFill>
+                  <a:srgbClr val="C084FC"/>
+                </a:solidFill>
+                <a:latin typeface="Consolas"/>
+              </a:rPr>
+              <a:t>import</a:t>
+            </a:r>
+            <a:r>
+              <a:rPr sz="950">
+                <a:solidFill>
+                  <a:srgbClr val="D4D4D8"/>
+                </a:solidFill>
+                <a:latin typeface="Consolas"/>
+              </a:rPr>
+              <a:t> SimpleCustomNode from </a:t>
+            </a:r>
+            <a:r>
+              <a:rPr sz="950">
+                <a:solidFill>
+                  <a:srgbClr val="34D399"/>
+                </a:solidFill>
+                <a:latin typeface="Consolas"/>
+              </a:rPr>
+              <a:t>'./components/SimpleCustomNode.vue'</a:t>
+            </a:r>
+          </a:p>
+          <a:p>
+            <a:pPr>
+              <a:lnSpc>
+                <a:spcPts val="1400"/>
+              </a:lnSpc>
+              <a:spcBef>
+                <a:spcPts val="0"/>
+              </a:spcBef>
+              <a:spcAft>
+                <a:spcPts val="0"/>
+              </a:spcAft>
+            </a:pPr>
+            <a:r>
+              <a:rPr sz="950">
+                <a:solidFill>
+                  <a:srgbClr val="D4D4D8"/>
+                </a:solidFill>
+                <a:latin typeface="Consolas"/>
+              </a:rPr>
+              <a:t/>
+            </a:r>
+          </a:p>
+          <a:p>
+            <a:pPr>
+              <a:lnSpc>
+                <a:spcPts val="1400"/>
+              </a:lnSpc>
+              <a:spcBef>
+                <a:spcPts val="0"/>
+              </a:spcBef>
+              <a:spcAft>
+                <a:spcPts val="0"/>
+              </a:spcAft>
+            </a:pPr>
+            <a:r>
+              <a:rPr sz="950">
+                <a:solidFill>
+                  <a:srgbClr val="64748B"/>
+                </a:solidFill>
+                <a:latin typeface="Consolas"/>
+              </a:rPr>
+              <a:t>/* ⚠️ 必須使用 markRaw 包裹以防止 Vue 深度 proxy 監聽，提升效能 */</a:t>
+            </a:r>
+          </a:p>
+          <a:p>
+            <a:pPr>
+              <a:lnSpc>
+                <a:spcPts val="1400"/>
+              </a:lnSpc>
+              <a:spcBef>
+                <a:spcPts val="0"/>
+              </a:spcBef>
+              <a:spcAft>
+                <a:spcPts val="0"/>
+              </a:spcAft>
+            </a:pPr>
+            <a:r>
+              <a:rPr sz="950">
+                <a:solidFill>
+                  <a:srgbClr val="C084FC"/>
+                </a:solidFill>
+                <a:latin typeface="Consolas"/>
+              </a:rPr>
               <a:t>const</a:t>
             </a:r>
             <a:r>
-              <a:rPr sz="1000">
+              <a:rPr sz="950">
                 <a:solidFill>
                   <a:srgbClr val="D4D4D8"/>
                 </a:solidFill>
                 <a:latin typeface="Consolas"/>
               </a:rPr>
-              <a:t> onConnect = (connection) =&gt; {</a:t>
+              <a:t> nodeTypes = {</a:t>
             </a:r>
           </a:p>
           <a:p>
             <a:pPr>
               <a:lnSpc>
-                <a:spcPts val="1500"/>
+                <a:spcPts val="1400"/>
               </a:lnSpc>
               <a:spcBef>
                 <a:spcPts val="0"/>
@@ -6680,19 +6153,19 @@
               </a:spcAft>
             </a:pPr>
             <a:r>
-              <a:rPr sz="1000">
+              <a:rPr sz="950">
                 <a:solidFill>
                   <a:srgbClr val="D4D4D8"/>
                 </a:solidFill>
                 <a:latin typeface="Consolas"/>
               </a:rPr>
-              <a:t>  edges.value.push({</a:t>
+              <a:t>  'simple-custom': markRaw(SimpleCustomNode),</a:t>
             </a:r>
           </a:p>
           <a:p>
             <a:pPr>
               <a:lnSpc>
-                <a:spcPts val="1500"/>
+                <a:spcPts val="1400"/>
               </a:lnSpc>
               <a:spcBef>
                 <a:spcPts val="0"/>
@@ -6702,37 +6175,143 @@
               </a:spcAft>
             </a:pPr>
             <a:r>
-              <a:rPr sz="1000">
+              <a:rPr sz="950">
                 <a:solidFill>
                   <a:srgbClr val="D4D4D8"/>
                 </a:solidFill>
                 <a:latin typeface="Consolas"/>
               </a:rPr>
-              <a:t>    id: </a:t>
-            </a:r>
-            <a:r>
-              <a:rPr sz="1000">
+              <a:t>}</a:t>
+            </a:r>
+          </a:p>
+          <a:p>
+            <a:pPr>
+              <a:lnSpc>
+                <a:spcPts val="1400"/>
+              </a:lnSpc>
+              <a:spcBef>
+                <a:spcPts val="0"/>
+              </a:spcBef>
+              <a:spcAft>
+                <a:spcPts val="0"/>
+              </a:spcAft>
+            </a:pPr>
+            <a:r>
+              <a:rPr sz="950">
+                <a:solidFill>
+                  <a:srgbClr val="FB7185"/>
+                </a:solidFill>
+                <a:latin typeface="Consolas"/>
+              </a:rPr>
+              <a:t>&lt;/script&gt;</a:t>
+            </a:r>
+          </a:p>
+          <a:p>
+            <a:pPr>
+              <a:lnSpc>
+                <a:spcPts val="1400"/>
+              </a:lnSpc>
+              <a:spcBef>
+                <a:spcPts val="0"/>
+              </a:spcBef>
+              <a:spcAft>
+                <a:spcPts val="0"/>
+              </a:spcAft>
+            </a:pPr>
+            <a:r>
+              <a:rPr sz="950">
+                <a:solidFill>
+                  <a:srgbClr val="D4D4D8"/>
+                </a:solidFill>
+                <a:latin typeface="Consolas"/>
+              </a:rPr>
+              <a:t/>
+            </a:r>
+          </a:p>
+          <a:p>
+            <a:pPr>
+              <a:lnSpc>
+                <a:spcPts val="1400"/>
+              </a:lnSpc>
+              <a:spcBef>
+                <a:spcPts val="0"/>
+              </a:spcBef>
+              <a:spcAft>
+                <a:spcPts val="0"/>
+              </a:spcAft>
+            </a:pPr>
+            <a:r>
+              <a:rPr sz="950">
+                <a:solidFill>
+                  <a:srgbClr val="FB7185"/>
+                </a:solidFill>
+                <a:latin typeface="Consolas"/>
+              </a:rPr>
+              <a:t>&lt;template&gt;</a:t>
+            </a:r>
+          </a:p>
+          <a:p>
+            <a:pPr>
+              <a:lnSpc>
+                <a:spcPts val="1400"/>
+              </a:lnSpc>
+              <a:spcBef>
+                <a:spcPts val="0"/>
+              </a:spcBef>
+              <a:spcAft>
+                <a:spcPts val="0"/>
+              </a:spcAft>
+            </a:pPr>
+            <a:r>
+              <a:rPr sz="950">
+                <a:solidFill>
+                  <a:srgbClr val="FB7185"/>
+                </a:solidFill>
+                <a:latin typeface="Consolas"/>
+              </a:rPr>
+              <a:t>  &lt;VueFlow </a:t>
+            </a:r>
+            <a:r>
+              <a:rPr sz="950">
+                <a:solidFill>
+                  <a:srgbClr val="818CF8"/>
+                </a:solidFill>
+                <a:latin typeface="Consolas"/>
+              </a:rPr>
+              <a:t>:node-types</a:t>
+            </a:r>
+            <a:r>
+              <a:rPr sz="950">
+                <a:solidFill>
+                  <a:srgbClr val="D4D4D8"/>
+                </a:solidFill>
+                <a:latin typeface="Consolas"/>
+              </a:rPr>
+              <a:t>=</a:t>
+            </a:r>
+            <a:r>
+              <a:rPr sz="950">
                 <a:solidFill>
                   <a:srgbClr val="34D399"/>
                 </a:solidFill>
                 <a:latin typeface="Consolas"/>
               </a:rPr>
-              <a:t>`e-${connection.source}-${connection.target}`</a:t>
-            </a:r>
-            <a:r>
-              <a:rPr sz="1000">
-                <a:solidFill>
-                  <a:srgbClr val="D4D4D8"/>
-                </a:solidFill>
-                <a:latin typeface="Consolas"/>
-              </a:rPr>
-              <a:t>,</a:t>
+              <a:t>"nodeTypes"</a:t>
+            </a:r>
+            <a:r>
+              <a:rPr sz="950">
+                <a:solidFill>
+                  <a:srgbClr val="FB7185"/>
+                </a:solidFill>
+                <a:latin typeface="Consolas"/>
+              </a:rPr>
+              <a:t> ... /&gt;</a:t>
             </a:r>
           </a:p>
           <a:p>
             <a:pPr>
               <a:lnSpc>
-                <a:spcPts val="1500"/>
+                <a:spcPts val="1400"/>
               </a:lnSpc>
               <a:spcBef>
                 <a:spcPts val="0"/>
@@ -6742,403 +6321,13 @@
               </a:spcAft>
             </a:pPr>
             <a:r>
-              <a:rPr sz="1000">
-                <a:solidFill>
-                  <a:srgbClr val="D4D4D8"/>
-                </a:solidFill>
-                <a:latin typeface="Consolas"/>
-              </a:rPr>
-              <a:t>    source: connection.source,</a:t>
-            </a:r>
-          </a:p>
-          <a:p>
-            <a:pPr>
-              <a:lnSpc>
-                <a:spcPts val="1500"/>
-              </a:lnSpc>
-              <a:spcBef>
-                <a:spcPts val="0"/>
-              </a:spcBef>
-              <a:spcAft>
-                <a:spcPts val="0"/>
-              </a:spcAft>
-            </a:pPr>
-            <a:r>
-              <a:rPr sz="1000">
-                <a:solidFill>
-                  <a:srgbClr val="D4D4D8"/>
-                </a:solidFill>
-                <a:latin typeface="Consolas"/>
-              </a:rPr>
-              <a:t>    target: connection.target,</a:t>
-            </a:r>
-          </a:p>
-          <a:p>
-            <a:pPr>
-              <a:lnSpc>
-                <a:spcPts val="1500"/>
-              </a:lnSpc>
-              <a:spcBef>
-                <a:spcPts val="0"/>
-              </a:spcBef>
-              <a:spcAft>
-                <a:spcPts val="0"/>
-              </a:spcAft>
-            </a:pPr>
-            <a:r>
-              <a:rPr sz="1000">
-                <a:solidFill>
-                  <a:srgbClr val="D4D4D8"/>
-                </a:solidFill>
-                <a:latin typeface="Consolas"/>
-              </a:rPr>
-              <a:t>    animated: </a:t>
-            </a:r>
-            <a:r>
-              <a:rPr sz="1000">
-                <a:solidFill>
-                  <a:srgbClr val="C084FC"/>
-                </a:solidFill>
-                <a:latin typeface="Consolas"/>
-              </a:rPr>
-              <a:t>true</a:t>
-            </a:r>
-            <a:r>
-              <a:rPr sz="1000">
-                <a:solidFill>
-                  <a:srgbClr val="D4D4D8"/>
-                </a:solidFill>
-                <a:latin typeface="Consolas"/>
-              </a:rPr>
-              <a:t>, </a:t>
-            </a:r>
-            <a:r>
-              <a:rPr sz="1000">
-                <a:solidFill>
-                  <a:srgbClr val="64748B"/>
-                </a:solidFill>
-                <a:latin typeface="Consolas"/>
-              </a:rPr>
-              <a:t>/* 動畫連線效果 */</a:t>
-            </a:r>
-          </a:p>
-          <a:p>
-            <a:pPr>
-              <a:lnSpc>
-                <a:spcPts val="1500"/>
-              </a:lnSpc>
-              <a:spcBef>
-                <a:spcPts val="0"/>
-              </a:spcBef>
-              <a:spcAft>
-                <a:spcPts val="0"/>
-              </a:spcAft>
-            </a:pPr>
-            <a:r>
-              <a:rPr sz="1000">
-                <a:solidFill>
-                  <a:srgbClr val="D4D4D8"/>
-                </a:solidFill>
-                <a:latin typeface="Consolas"/>
-              </a:rPr>
-              <a:t>    style: { stroke: </a:t>
-            </a:r>
-            <a:r>
-              <a:rPr sz="1000">
-                <a:solidFill>
-                  <a:srgbClr val="34D399"/>
-                </a:solidFill>
-                <a:latin typeface="Consolas"/>
-              </a:rPr>
-              <a:t>'#10b981'</a:t>
-            </a:r>
-            <a:r>
-              <a:rPr sz="1000">
-                <a:solidFill>
-                  <a:srgbClr val="D4D4D8"/>
-                </a:solidFill>
-                <a:latin typeface="Consolas"/>
-              </a:rPr>
-              <a:t> },</a:t>
-            </a:r>
-          </a:p>
-          <a:p>
-            <a:pPr>
-              <a:lnSpc>
-                <a:spcPts val="1500"/>
-              </a:lnSpc>
-              <a:spcBef>
-                <a:spcPts val="0"/>
-              </a:spcBef>
-              <a:spcAft>
-                <a:spcPts val="0"/>
-              </a:spcAft>
-            </a:pPr>
-            <a:r>
-              <a:rPr sz="1000">
-                <a:solidFill>
-                  <a:srgbClr val="D4D4D8"/>
-                </a:solidFill>
-                <a:latin typeface="Consolas"/>
-              </a:rPr>
-              <a:t>  })</a:t>
-            </a:r>
-          </a:p>
-          <a:p>
-            <a:pPr>
-              <a:lnSpc>
-                <a:spcPts val="1500"/>
-              </a:lnSpc>
-              <a:spcBef>
-                <a:spcPts val="0"/>
-              </a:spcBef>
-              <a:spcAft>
-                <a:spcPts val="0"/>
-              </a:spcAft>
-            </a:pPr>
-            <a:r>
-              <a:rPr sz="1000">
-                <a:solidFill>
-                  <a:srgbClr val="D4D4D8"/>
-                </a:solidFill>
-                <a:latin typeface="Consolas"/>
-              </a:rPr>
-              <a:t>}</a:t>
-            </a:r>
-          </a:p>
-          <a:p>
-            <a:pPr>
-              <a:lnSpc>
-                <a:spcPts val="1500"/>
-              </a:lnSpc>
-              <a:spcBef>
-                <a:spcPts val="0"/>
-              </a:spcBef>
-              <a:spcAft>
-                <a:spcPts val="0"/>
-              </a:spcAft>
-            </a:pPr>
-            <a:r>
-              <a:rPr sz="1000">
-                <a:solidFill>
-                  <a:srgbClr val="D4D4D8"/>
-                </a:solidFill>
-                <a:latin typeface="Consolas"/>
-              </a:rPr>
-              <a:t/>
-            </a:r>
-          </a:p>
-          <a:p>
-            <a:pPr>
-              <a:lnSpc>
-                <a:spcPts val="1500"/>
-              </a:lnSpc>
-              <a:spcBef>
-                <a:spcPts val="0"/>
-              </a:spcBef>
-              <a:spcAft>
-                <a:spcPts val="0"/>
-              </a:spcAft>
-            </a:pPr>
-            <a:r>
-              <a:rPr sz="1000">
-                <a:solidFill>
-                  <a:srgbClr val="64748B"/>
-                </a:solidFill>
-                <a:latin typeface="Consolas"/>
-              </a:rPr>
-              <a:t>&lt;!-- Template 整合外掛 --&gt;</a:t>
-            </a:r>
-          </a:p>
-          <a:p>
-            <a:pPr>
-              <a:lnSpc>
-                <a:spcPts val="1500"/>
-              </a:lnSpc>
-              <a:spcBef>
-                <a:spcPts val="0"/>
-              </a:spcBef>
-              <a:spcAft>
-                <a:spcPts val="0"/>
-              </a:spcAft>
-            </a:pPr>
-            <a:r>
-              <a:rPr sz="1000">
+              <a:rPr sz="950">
                 <a:solidFill>
                   <a:srgbClr val="FB7185"/>
                 </a:solidFill>
                 <a:latin typeface="Consolas"/>
               </a:rPr>
-              <a:t>&lt;VueFlow</a:t>
-            </a:r>
-            <a:r>
-              <a:rPr sz="1000">
-                <a:solidFill>
-                  <a:srgbClr val="D4D4D8"/>
-                </a:solidFill>
-                <a:latin typeface="Consolas"/>
-              </a:rPr>
-              <a:t> ... </a:t>
-            </a:r>
-            <a:r>
-              <a:rPr sz="1000">
-                <a:solidFill>
-                  <a:srgbClr val="818CF8"/>
-                </a:solidFill>
-                <a:latin typeface="Consolas"/>
-              </a:rPr>
-              <a:t>@connect</a:t>
-            </a:r>
-            <a:r>
-              <a:rPr sz="1000">
-                <a:solidFill>
-                  <a:srgbClr val="D4D4D8"/>
-                </a:solidFill>
-                <a:latin typeface="Consolas"/>
-              </a:rPr>
-              <a:t>=</a:t>
-            </a:r>
-            <a:r>
-              <a:rPr sz="1000">
-                <a:solidFill>
-                  <a:srgbClr val="34D399"/>
-                </a:solidFill>
-                <a:latin typeface="Consolas"/>
-              </a:rPr>
-              <a:t>"onConnect"</a:t>
-            </a:r>
-            <a:r>
-              <a:rPr sz="1000">
-                <a:solidFill>
-                  <a:srgbClr val="FB7185"/>
-                </a:solidFill>
-                <a:latin typeface="Consolas"/>
-              </a:rPr>
-              <a:t>&gt;</a:t>
-            </a:r>
-          </a:p>
-          <a:p>
-            <a:pPr>
-              <a:lnSpc>
-                <a:spcPts val="1500"/>
-              </a:lnSpc>
-              <a:spcBef>
-                <a:spcPts val="0"/>
-              </a:spcBef>
-              <a:spcAft>
-                <a:spcPts val="0"/>
-              </a:spcAft>
-            </a:pPr>
-            <a:r>
-              <a:rPr sz="1000">
-                <a:solidFill>
-                  <a:srgbClr val="FB7185"/>
-                </a:solidFill>
-                <a:latin typeface="Consolas"/>
-              </a:rPr>
-              <a:t>  &lt;Background </a:t>
-            </a:r>
-            <a:r>
-              <a:rPr sz="1000">
-                <a:solidFill>
-                  <a:srgbClr val="818CF8"/>
-                </a:solidFill>
-                <a:latin typeface="Consolas"/>
-              </a:rPr>
-              <a:t>:gap</a:t>
-            </a:r>
-            <a:r>
-              <a:rPr sz="1000">
-                <a:solidFill>
-                  <a:srgbClr val="D4D4D8"/>
-                </a:solidFill>
-                <a:latin typeface="Consolas"/>
-              </a:rPr>
-              <a:t>=</a:t>
-            </a:r>
-            <a:r>
-              <a:rPr sz="1000">
-                <a:solidFill>
-                  <a:srgbClr val="34D399"/>
-                </a:solidFill>
-                <a:latin typeface="Consolas"/>
-              </a:rPr>
-              <a:t>"20"</a:t>
-            </a:r>
-            <a:r>
-              <a:rPr sz="1000">
-                <a:solidFill>
-                  <a:srgbClr val="FB7185"/>
-                </a:solidFill>
-                <a:latin typeface="Consolas"/>
-              </a:rPr>
-              <a:t> /&gt;</a:t>
-            </a:r>
-          </a:p>
-          <a:p>
-            <a:pPr>
-              <a:lnSpc>
-                <a:spcPts val="1500"/>
-              </a:lnSpc>
-              <a:spcBef>
-                <a:spcPts val="0"/>
-              </a:spcBef>
-              <a:spcAft>
-                <a:spcPts val="0"/>
-              </a:spcAft>
-            </a:pPr>
-            <a:r>
-              <a:rPr sz="1000">
-                <a:solidFill>
-                  <a:srgbClr val="FB7185"/>
-                </a:solidFill>
-                <a:latin typeface="Consolas"/>
-              </a:rPr>
-              <a:t>  &lt;Controls /&gt;</a:t>
-            </a:r>
-          </a:p>
-          <a:p>
-            <a:pPr>
-              <a:lnSpc>
-                <a:spcPts val="1500"/>
-              </a:lnSpc>
-              <a:spcBef>
-                <a:spcPts val="0"/>
-              </a:spcBef>
-              <a:spcAft>
-                <a:spcPts val="0"/>
-              </a:spcAft>
-            </a:pPr>
-            <a:r>
-              <a:rPr sz="1000">
-                <a:solidFill>
-                  <a:srgbClr val="FB7185"/>
-                </a:solidFill>
-                <a:latin typeface="Consolas"/>
-              </a:rPr>
-              <a:t>  &lt;MiniMap /&gt;</a:t>
-            </a:r>
-          </a:p>
-          <a:p>
-            <a:pPr>
-              <a:lnSpc>
-                <a:spcPts val="1500"/>
-              </a:lnSpc>
-              <a:spcBef>
-                <a:spcPts val="0"/>
-              </a:spcBef>
-              <a:spcAft>
-                <a:spcPts val="0"/>
-              </a:spcAft>
-            </a:pPr>
-            <a:r>
-              <a:rPr sz="1000">
-                <a:solidFill>
-                  <a:srgbClr val="FB7185"/>
-                </a:solidFill>
-                <a:latin typeface="Consolas"/>
-              </a:rPr>
-              <a:t>&lt;/VueFlow&gt;</a:t>
+              <a:t>&lt;/template&gt;</a:t>
             </a:r>
           </a:p>
         </p:txBody>
@@ -7167,10 +6356,804 @@
           <a:p>
             <a:pPr>
               <a:spcBef>
-                <a:spcPts val="600"/>
-              </a:spcBef>
-              <a:spcAft>
-                <a:spcPts val="400"/>
+                <a:spcPts val="500"/>
+              </a:spcBef>
+              <a:spcAft>
+                <a:spcPts val="300"/>
+              </a:spcAft>
+            </a:pPr>
+            <a:r>
+              <a:rPr sz="1450">
+                <a:solidFill>
+                  <a:srgbClr val="10B981"/>
+                </a:solidFill>
+              </a:rPr>
+              <a:t>⚠️  </a:t>
+            </a:r>
+            <a:r>
+              <a:rPr sz="1450" b="1">
+                <a:solidFill>
+                  <a:srgbClr val="F8FAFC"/>
+                </a:solidFill>
+              </a:rPr>
+              <a:t>效能關鍵：markRaw()</a:t>
+            </a:r>
+            <a:r>
+              <a:rPr sz="1300">
+                <a:solidFill>
+                  <a:srgbClr val="94A3B8"/>
+                </a:solidFill>
+              </a:rPr>
+              <a:t>  —  Vue 3 預設會遞迴地將所有 reactive 變數轉為 Proxy。若不使用 markRaw，Vue Flow 內部的節點實例會被頻繁 Proxy 處理，導致拖拽時嚴重卡頓與效能損耗。</a:t>
+            </a:r>
+          </a:p>
+          <a:p>
+            <a:pPr>
+              <a:spcBef>
+                <a:spcPts val="500"/>
+              </a:spcBef>
+              <a:spcAft>
+                <a:spcPts val="300"/>
+              </a:spcAft>
+            </a:pPr>
+            <a:r>
+              <a:rPr sz="1450">
+                <a:solidFill>
+                  <a:srgbClr val="10B981"/>
+                </a:solidFill>
+              </a:rPr>
+              <a:t>🏷️  </a:t>
+            </a:r>
+            <a:r>
+              <a:rPr sz="1450" b="1">
+                <a:solidFill>
+                  <a:srgbClr val="F8FAFC"/>
+                </a:solidFill>
+              </a:rPr>
+              <a:t>自訂 nodeTypes 對應</a:t>
+            </a:r>
+            <a:r>
+              <a:rPr sz="1300">
+                <a:solidFill>
+                  <a:srgbClr val="94A3B8"/>
+                </a:solidFill>
+              </a:rPr>
+              <a:t>  —  以 key-value 形式對應自訂名稱與元件。在 initial-elements.ts 中只需宣告 type: 'simple-custom' 即可。</a:t>
+            </a:r>
+          </a:p>
+          <a:p>
+            <a:pPr>
+              <a:spcBef>
+                <a:spcPts val="500"/>
+              </a:spcBef>
+              <a:spcAft>
+                <a:spcPts val="300"/>
+              </a:spcAft>
+            </a:pPr>
+            <a:r>
+              <a:rPr sz="1450">
+                <a:solidFill>
+                  <a:srgbClr val="10B981"/>
+                </a:solidFill>
+              </a:rPr>
+              <a:t>⚡  </a:t>
+            </a:r>
+            <a:r>
+              <a:rPr sz="1450" b="1">
+                <a:solidFill>
+                  <a:srgbClr val="F8FAFC"/>
+                </a:solidFill>
+              </a:rPr>
+              <a:t>資料傳遞方式</a:t>
+            </a:r>
+            <a:r>
+              <a:rPr sz="1300">
+                <a:solidFill>
+                  <a:srgbClr val="94A3B8"/>
+                </a:solidFill>
+              </a:rPr>
+              <a:t>  —  在 nodes 資料定義中的 data 欄位，會自動作為 props 被傳遞至自定義元件內部。</a:t>
+            </a:r>
+          </a:p>
+        </p:txBody>
+      </p:sp>
+    </p:spTree>
+  </p:cSld>
+  <p:clrMapOvr>
+    <a:masterClrMapping/>
+  </p:clrMapOvr>
+</p:sld>
+</file>
+
+<file path=ppt/slides/slide6.xml><?xml version="1.0" encoding="utf-8"?>
+<p:sld xmlns:a="http://schemas.openxmlformats.org/drawingml/2006/main" xmlns:p="http://schemas.openxmlformats.org/presentationml/2006/main" xmlns:r="http://schemas.openxmlformats.org/officeDocument/2006/relationships">
+  <p:cSld>
+    <p:bg>
+      <p:bgPr>
+        <a:solidFill>
+          <a:srgbClr val="0F172A"/>
+        </a:solidFill>
+        <a:effectLst/>
+      </p:bgPr>
+    </p:bg>
+    <p:spTree>
+      <p:nvGrpSpPr>
+        <p:cNvPr id="1" name=""/>
+        <p:cNvGrpSpPr/>
+        <p:nvPr/>
+      </p:nvGrpSpPr>
+      <p:grpSpPr/>
+      <p:sp>
+        <p:nvSpPr>
+          <p:cNvPr id="2" name="TextBox 1"/>
+          <p:cNvSpPr txBox="1"/>
+          <p:nvPr/>
+        </p:nvSpPr>
+        <p:spPr>
+          <a:xfrm>
+            <a:off x="731520" y="457200"/>
+            <a:ext cx="4572000" cy="365760"/>
+          </a:xfrm>
+          <a:prstGeom prst="rect">
+            <a:avLst/>
+          </a:prstGeom>
+          <a:noFill/>
+        </p:spPr>
+        <p:txBody>
+          <a:bodyPr wrap="square">
+            <a:spAutoFit/>
+          </a:bodyPr>
+          <a:lstStyle/>
+          <a:p>
+            <a:pPr algn="l">
+              <a:defRPr sz="1300" b="1">
+                <a:solidFill>
+                  <a:srgbClr val="10B981"/>
+                </a:solidFill>
+                <a:latin typeface="Calibri"/>
+              </a:defRPr>
+            </a:pPr>
+            <a:r>
+              <a:t>05  CONNECTIONS &amp; PLUGINS</a:t>
+            </a:r>
+          </a:p>
+        </p:txBody>
+      </p:sp>
+      <p:sp>
+        <p:nvSpPr>
+          <p:cNvPr id="3" name="TextBox 2"/>
+          <p:cNvSpPr txBox="1"/>
+          <p:nvPr/>
+        </p:nvSpPr>
+        <p:spPr>
+          <a:xfrm>
+            <a:off x="731520" y="914400"/>
+            <a:ext cx="10058400" cy="731520"/>
+          </a:xfrm>
+          <a:prstGeom prst="rect">
+            <a:avLst/>
+          </a:prstGeom>
+          <a:noFill/>
+        </p:spPr>
+        <p:txBody>
+          <a:bodyPr wrap="square">
+            <a:spAutoFit/>
+          </a:bodyPr>
+          <a:lstStyle/>
+          <a:p>
+            <a:pPr algn="l">
+              <a:defRPr sz="3200" b="1">
+                <a:solidFill>
+                  <a:srgbClr val="F8FAFC"/>
+                </a:solidFill>
+                <a:latin typeface="Calibri"/>
+              </a:defRPr>
+            </a:pPr>
+            <a:r>
+              <a:t>連線處理與三大實用外掛</a:t>
+            </a:r>
+          </a:p>
+        </p:txBody>
+      </p:sp>
+      <p:sp>
+        <p:nvSpPr>
+          <p:cNvPr id="4" name="Rectangle 3"/>
+          <p:cNvSpPr/>
+          <p:nvPr/>
+        </p:nvSpPr>
+        <p:spPr>
+          <a:xfrm>
+            <a:off x="731520" y="1645920"/>
+            <a:ext cx="1097280" cy="38100"/>
+          </a:xfrm>
+          <a:prstGeom prst="rect">
+            <a:avLst/>
+          </a:prstGeom>
+          <a:solidFill>
+            <a:srgbClr val="10B981"/>
+          </a:solidFill>
+          <a:ln>
+            <a:noFill/>
+          </a:ln>
+        </p:spPr>
+        <p:style>
+          <a:lnRef idx="1">
+            <a:schemeClr val="accent1"/>
+          </a:lnRef>
+          <a:fillRef idx="3">
+            <a:schemeClr val="accent1"/>
+          </a:fillRef>
+          <a:effectRef idx="2">
+            <a:schemeClr val="accent1"/>
+          </a:effectRef>
+          <a:fontRef idx="minor">
+            <a:schemeClr val="lt1"/>
+          </a:fontRef>
+        </p:style>
+        <p:txBody>
+          <a:bodyPr rtlCol="0" anchor="ctr"/>
+          <a:lstStyle/>
+          <a:p>
+            <a:pPr algn="ctr"/>
+          </a:p>
+        </p:txBody>
+      </p:sp>
+      <p:sp>
+        <p:nvSpPr>
+          <p:cNvPr id="5" name="Rounded Rectangle 4"/>
+          <p:cNvSpPr/>
+          <p:nvPr/>
+        </p:nvSpPr>
+        <p:spPr>
+          <a:xfrm>
+            <a:off x="640080" y="1920240"/>
+            <a:ext cx="5669280" cy="4297680"/>
+          </a:xfrm>
+          <a:prstGeom prst="roundRect">
+            <a:avLst>
+              <a:gd name="adj" fmla="val 5000"/>
+            </a:avLst>
+          </a:prstGeom>
+          <a:solidFill>
+            <a:srgbClr val="0B0F19"/>
+          </a:solidFill>
+          <a:ln>
+            <a:noFill/>
+          </a:ln>
+          <a:effectLst/>
+        </p:spPr>
+        <p:style>
+          <a:lnRef idx="1">
+            <a:schemeClr val="accent1"/>
+          </a:lnRef>
+          <a:fillRef idx="3">
+            <a:schemeClr val="accent1"/>
+          </a:fillRef>
+          <a:effectRef idx="2">
+            <a:schemeClr val="accent1"/>
+          </a:effectRef>
+          <a:fontRef idx="minor">
+            <a:schemeClr val="lt1"/>
+          </a:fontRef>
+        </p:style>
+        <p:txBody>
+          <a:bodyPr rtlCol="0" anchor="ctr"/>
+          <a:lstStyle/>
+          <a:p>
+            <a:pPr algn="ctr"/>
+          </a:p>
+        </p:txBody>
+      </p:sp>
+      <p:sp>
+        <p:nvSpPr>
+          <p:cNvPr id="6" name="TextBox 5"/>
+          <p:cNvSpPr txBox="1"/>
+          <p:nvPr/>
+        </p:nvSpPr>
+        <p:spPr>
+          <a:xfrm>
+            <a:off x="731520" y="2011680"/>
+            <a:ext cx="5486400" cy="4114800"/>
+          </a:xfrm>
+          <a:prstGeom prst="rect">
+            <a:avLst/>
+          </a:prstGeom>
+          <a:noFill/>
+        </p:spPr>
+        <p:txBody>
+          <a:bodyPr wrap="square">
+            <a:spAutoFit/>
+          </a:bodyPr>
+          <a:lstStyle/>
+          <a:p>
+            <a:pPr>
+              <a:lnSpc>
+                <a:spcPts val="1400"/>
+              </a:lnSpc>
+              <a:spcBef>
+                <a:spcPts val="0"/>
+              </a:spcBef>
+              <a:spcAft>
+                <a:spcPts val="0"/>
+              </a:spcAft>
+            </a:pPr>
+            <a:r>
+              <a:rPr sz="950">
+                <a:solidFill>
+                  <a:srgbClr val="64748B"/>
+                </a:solidFill>
+                <a:latin typeface="Consolas"/>
+              </a:rPr>
+              <a:t>/* App.vue - @connect 事件處理 */</a:t>
+            </a:r>
+          </a:p>
+          <a:p>
+            <a:pPr>
+              <a:lnSpc>
+                <a:spcPts val="1400"/>
+              </a:lnSpc>
+              <a:spcBef>
+                <a:spcPts val="0"/>
+              </a:spcBef>
+              <a:spcAft>
+                <a:spcPts val="0"/>
+              </a:spcAft>
+            </a:pPr>
+            <a:r>
+              <a:rPr sz="950">
+                <a:solidFill>
+                  <a:srgbClr val="C084FC"/>
+                </a:solidFill>
+                <a:latin typeface="Consolas"/>
+              </a:rPr>
+              <a:t>const</a:t>
+            </a:r>
+            <a:r>
+              <a:rPr sz="950">
+                <a:solidFill>
+                  <a:srgbClr val="D4D4D8"/>
+                </a:solidFill>
+                <a:latin typeface="Consolas"/>
+              </a:rPr>
+              <a:t> onConnect = (connection) =&gt; {</a:t>
+            </a:r>
+          </a:p>
+          <a:p>
+            <a:pPr>
+              <a:lnSpc>
+                <a:spcPts val="1400"/>
+              </a:lnSpc>
+              <a:spcBef>
+                <a:spcPts val="0"/>
+              </a:spcBef>
+              <a:spcAft>
+                <a:spcPts val="0"/>
+              </a:spcAft>
+            </a:pPr>
+            <a:r>
+              <a:rPr sz="950">
+                <a:solidFill>
+                  <a:srgbClr val="64748B"/>
+                </a:solidFill>
+                <a:latin typeface="Consolas"/>
+              </a:rPr>
+              <a:t>  // 當使用者在節點間拉出連線時，將新連線推入 edges 陣列</a:t>
+            </a:r>
+          </a:p>
+          <a:p>
+            <a:pPr>
+              <a:lnSpc>
+                <a:spcPts val="1400"/>
+              </a:lnSpc>
+              <a:spcBef>
+                <a:spcPts val="0"/>
+              </a:spcBef>
+              <a:spcAft>
+                <a:spcPts val="0"/>
+              </a:spcAft>
+            </a:pPr>
+            <a:r>
+              <a:rPr sz="950">
+                <a:solidFill>
+                  <a:srgbClr val="D4D4D8"/>
+                </a:solidFill>
+                <a:latin typeface="Consolas"/>
+              </a:rPr>
+              <a:t>  edges.value.push({</a:t>
+            </a:r>
+          </a:p>
+          <a:p>
+            <a:pPr>
+              <a:lnSpc>
+                <a:spcPts val="1400"/>
+              </a:lnSpc>
+              <a:spcBef>
+                <a:spcPts val="0"/>
+              </a:spcBef>
+              <a:spcAft>
+                <a:spcPts val="0"/>
+              </a:spcAft>
+            </a:pPr>
+            <a:r>
+              <a:rPr sz="950">
+                <a:solidFill>
+                  <a:srgbClr val="D4D4D8"/>
+                </a:solidFill>
+                <a:latin typeface="Consolas"/>
+              </a:rPr>
+              <a:t>    id: </a:t>
+            </a:r>
+            <a:r>
+              <a:rPr sz="950">
+                <a:solidFill>
+                  <a:srgbClr val="34D399"/>
+                </a:solidFill>
+                <a:latin typeface="Consolas"/>
+              </a:rPr>
+              <a:t>`e-${connection.source}-${connection.target}`</a:t>
+            </a:r>
+            <a:r>
+              <a:rPr sz="950">
+                <a:solidFill>
+                  <a:srgbClr val="D4D4D8"/>
+                </a:solidFill>
+                <a:latin typeface="Consolas"/>
+              </a:rPr>
+              <a:t>,</a:t>
+            </a:r>
+          </a:p>
+          <a:p>
+            <a:pPr>
+              <a:lnSpc>
+                <a:spcPts val="1400"/>
+              </a:lnSpc>
+              <a:spcBef>
+                <a:spcPts val="0"/>
+              </a:spcBef>
+              <a:spcAft>
+                <a:spcPts val="0"/>
+              </a:spcAft>
+            </a:pPr>
+            <a:r>
+              <a:rPr sz="950">
+                <a:solidFill>
+                  <a:srgbClr val="D4D4D8"/>
+                </a:solidFill>
+                <a:latin typeface="Consolas"/>
+              </a:rPr>
+              <a:t>    source: connection.source,</a:t>
+            </a:r>
+          </a:p>
+          <a:p>
+            <a:pPr>
+              <a:lnSpc>
+                <a:spcPts val="1400"/>
+              </a:lnSpc>
+              <a:spcBef>
+                <a:spcPts val="0"/>
+              </a:spcBef>
+              <a:spcAft>
+                <a:spcPts val="0"/>
+              </a:spcAft>
+            </a:pPr>
+            <a:r>
+              <a:rPr sz="950">
+                <a:solidFill>
+                  <a:srgbClr val="D4D4D8"/>
+                </a:solidFill>
+                <a:latin typeface="Consolas"/>
+              </a:rPr>
+              <a:t>    target: connection.target,</a:t>
+            </a:r>
+          </a:p>
+          <a:p>
+            <a:pPr>
+              <a:lnSpc>
+                <a:spcPts val="1400"/>
+              </a:lnSpc>
+              <a:spcBef>
+                <a:spcPts val="0"/>
+              </a:spcBef>
+              <a:spcAft>
+                <a:spcPts val="0"/>
+              </a:spcAft>
+            </a:pPr>
+            <a:r>
+              <a:rPr sz="950">
+                <a:solidFill>
+                  <a:srgbClr val="D4D4D8"/>
+                </a:solidFill>
+                <a:latin typeface="Consolas"/>
+              </a:rPr>
+              <a:t>    animated: </a:t>
+            </a:r>
+            <a:r>
+              <a:rPr sz="950">
+                <a:solidFill>
+                  <a:srgbClr val="C084FC"/>
+                </a:solidFill>
+                <a:latin typeface="Consolas"/>
+              </a:rPr>
+              <a:t>true</a:t>
+            </a:r>
+            <a:r>
+              <a:rPr sz="950">
+                <a:solidFill>
+                  <a:srgbClr val="D4D4D8"/>
+                </a:solidFill>
+                <a:latin typeface="Consolas"/>
+              </a:rPr>
+              <a:t>,</a:t>
+            </a:r>
+          </a:p>
+          <a:p>
+            <a:pPr>
+              <a:lnSpc>
+                <a:spcPts val="1400"/>
+              </a:lnSpc>
+              <a:spcBef>
+                <a:spcPts val="0"/>
+              </a:spcBef>
+              <a:spcAft>
+                <a:spcPts val="0"/>
+              </a:spcAft>
+            </a:pPr>
+            <a:r>
+              <a:rPr sz="950">
+                <a:solidFill>
+                  <a:srgbClr val="D4D4D8"/>
+                </a:solidFill>
+                <a:latin typeface="Consolas"/>
+              </a:rPr>
+              <a:t>    style: { stroke: </a:t>
+            </a:r>
+            <a:r>
+              <a:rPr sz="950">
+                <a:solidFill>
+                  <a:srgbClr val="34D399"/>
+                </a:solidFill>
+                <a:latin typeface="Consolas"/>
+              </a:rPr>
+              <a:t>'#10b981'</a:t>
+            </a:r>
+            <a:r>
+              <a:rPr sz="950">
+                <a:solidFill>
+                  <a:srgbClr val="D4D4D8"/>
+                </a:solidFill>
+                <a:latin typeface="Consolas"/>
+              </a:rPr>
+              <a:t> },</a:t>
+            </a:r>
+          </a:p>
+          <a:p>
+            <a:pPr>
+              <a:lnSpc>
+                <a:spcPts val="1400"/>
+              </a:lnSpc>
+              <a:spcBef>
+                <a:spcPts val="0"/>
+              </a:spcBef>
+              <a:spcAft>
+                <a:spcPts val="0"/>
+              </a:spcAft>
+            </a:pPr>
+            <a:r>
+              <a:rPr sz="950">
+                <a:solidFill>
+                  <a:srgbClr val="D4D4D8"/>
+                </a:solidFill>
+                <a:latin typeface="Consolas"/>
+              </a:rPr>
+              <a:t>  })</a:t>
+            </a:r>
+          </a:p>
+          <a:p>
+            <a:pPr>
+              <a:lnSpc>
+                <a:spcPts val="1400"/>
+              </a:lnSpc>
+              <a:spcBef>
+                <a:spcPts val="0"/>
+              </a:spcBef>
+              <a:spcAft>
+                <a:spcPts val="0"/>
+              </a:spcAft>
+            </a:pPr>
+            <a:r>
+              <a:rPr sz="950">
+                <a:solidFill>
+                  <a:srgbClr val="D4D4D8"/>
+                </a:solidFill>
+                <a:latin typeface="Consolas"/>
+              </a:rPr>
+              <a:t>}</a:t>
+            </a:r>
+          </a:p>
+          <a:p>
+            <a:pPr>
+              <a:lnSpc>
+                <a:spcPts val="1400"/>
+              </a:lnSpc>
+              <a:spcBef>
+                <a:spcPts val="0"/>
+              </a:spcBef>
+              <a:spcAft>
+                <a:spcPts val="0"/>
+              </a:spcAft>
+            </a:pPr>
+            <a:r>
+              <a:rPr sz="950">
+                <a:solidFill>
+                  <a:srgbClr val="D4D4D8"/>
+                </a:solidFill>
+                <a:latin typeface="Consolas"/>
+              </a:rPr>
+              <a:t/>
+            </a:r>
+          </a:p>
+          <a:p>
+            <a:pPr>
+              <a:lnSpc>
+                <a:spcPts val="1400"/>
+              </a:lnSpc>
+              <a:spcBef>
+                <a:spcPts val="0"/>
+              </a:spcBef>
+              <a:spcAft>
+                <a:spcPts val="0"/>
+              </a:spcAft>
+            </a:pPr>
+            <a:r>
+              <a:rPr sz="950">
+                <a:solidFill>
+                  <a:srgbClr val="64748B"/>
+                </a:solidFill>
+                <a:latin typeface="Consolas"/>
+              </a:rPr>
+              <a:t>&lt;!-- Template 整合外掛 --&gt;</a:t>
+            </a:r>
+          </a:p>
+          <a:p>
+            <a:pPr>
+              <a:lnSpc>
+                <a:spcPts val="1400"/>
+              </a:lnSpc>
+              <a:spcBef>
+                <a:spcPts val="0"/>
+              </a:spcBef>
+              <a:spcAft>
+                <a:spcPts val="0"/>
+              </a:spcAft>
+            </a:pPr>
+            <a:r>
+              <a:rPr sz="950">
+                <a:solidFill>
+                  <a:srgbClr val="FB7185"/>
+                </a:solidFill>
+                <a:latin typeface="Consolas"/>
+              </a:rPr>
+              <a:t>&lt;VueFlow :nodes :edges :node-types="nodeTypes" @connect="onConnect"&gt;</a:t>
+            </a:r>
+          </a:p>
+          <a:p>
+            <a:pPr>
+              <a:lnSpc>
+                <a:spcPts val="1400"/>
+              </a:lnSpc>
+              <a:spcBef>
+                <a:spcPts val="0"/>
+              </a:spcBef>
+              <a:spcAft>
+                <a:spcPts val="0"/>
+              </a:spcAft>
+            </a:pPr>
+            <a:r>
+              <a:rPr sz="950">
+                <a:solidFill>
+                  <a:srgbClr val="FB7185"/>
+                </a:solidFill>
+                <a:latin typeface="Consolas"/>
+              </a:rPr>
+              <a:t>  &lt;Background :gap="20" /&gt;</a:t>
+            </a:r>
+          </a:p>
+          <a:p>
+            <a:pPr>
+              <a:lnSpc>
+                <a:spcPts val="1400"/>
+              </a:lnSpc>
+              <a:spcBef>
+                <a:spcPts val="0"/>
+              </a:spcBef>
+              <a:spcAft>
+                <a:spcPts val="0"/>
+              </a:spcAft>
+            </a:pPr>
+            <a:r>
+              <a:rPr sz="950">
+                <a:solidFill>
+                  <a:srgbClr val="FB7185"/>
+                </a:solidFill>
+                <a:latin typeface="Consolas"/>
+              </a:rPr>
+              <a:t>  &lt;Controls /&gt;</a:t>
+            </a:r>
+          </a:p>
+          <a:p>
+            <a:pPr>
+              <a:lnSpc>
+                <a:spcPts val="1400"/>
+              </a:lnSpc>
+              <a:spcBef>
+                <a:spcPts val="0"/>
+              </a:spcBef>
+              <a:spcAft>
+                <a:spcPts val="0"/>
+              </a:spcAft>
+            </a:pPr>
+            <a:r>
+              <a:rPr sz="950">
+                <a:solidFill>
+                  <a:srgbClr val="FB7185"/>
+                </a:solidFill>
+                <a:latin typeface="Consolas"/>
+              </a:rPr>
+              <a:t>  &lt;MiniMap /&gt;</a:t>
+            </a:r>
+          </a:p>
+          <a:p>
+            <a:pPr>
+              <a:lnSpc>
+                <a:spcPts val="1400"/>
+              </a:lnSpc>
+              <a:spcBef>
+                <a:spcPts val="0"/>
+              </a:spcBef>
+              <a:spcAft>
+                <a:spcPts val="0"/>
+              </a:spcAft>
+            </a:pPr>
+            <a:r>
+              <a:rPr sz="950">
+                <a:solidFill>
+                  <a:srgbClr val="FB7185"/>
+                </a:solidFill>
+                <a:latin typeface="Consolas"/>
+              </a:rPr>
+              <a:t>&lt;/VueFlow&gt;</a:t>
+            </a:r>
+          </a:p>
+        </p:txBody>
+      </p:sp>
+      <p:sp>
+        <p:nvSpPr>
+          <p:cNvPr id="7" name="TextBox 6"/>
+          <p:cNvSpPr txBox="1"/>
+          <p:nvPr/>
+        </p:nvSpPr>
+        <p:spPr>
+          <a:xfrm>
+            <a:off x="6583680" y="2011680"/>
+            <a:ext cx="4846320" cy="4114800"/>
+          </a:xfrm>
+          <a:prstGeom prst="rect">
+            <a:avLst/>
+          </a:prstGeom>
+          <a:noFill/>
+        </p:spPr>
+        <p:txBody>
+          <a:bodyPr wrap="square">
+            <a:spAutoFit/>
+          </a:bodyPr>
+          <a:lstStyle/>
+          <a:p>
+            <a:pPr>
+              <a:spcBef>
+                <a:spcPts val="500"/>
+              </a:spcBef>
+              <a:spcAft>
+                <a:spcPts val="300"/>
               </a:spcAft>
             </a:pPr>
             <a:r>
@@ -7187,7 +7170,7 @@
                   <a:srgbClr val="F8FAFC"/>
                 </a:solidFill>
               </a:rPr>
-              <a:t>@connect 連線事件</a:t>
+              <a:t>@connect 連線捕獲</a:t>
             </a:r>
             <a:r>
               <a:rPr sz="1250">
@@ -7195,16 +7178,16 @@
                   <a:srgbClr val="94A3B8"/>
                 </a:solidFill>
               </a:rPr>
-              <a:t>  —  當使用者完成滑鼠拉線，將 Connection 連接規格（source, target）轉化為真正的 Edge，推入 edges 響應式陣列。</a:t>
-            </a:r>
-          </a:p>
-          <a:p>
-            <a:pPr>
-              <a:spcBef>
-                <a:spcPts val="600"/>
-              </a:spcBef>
-              <a:spcAft>
-                <a:spcPts val="400"/>
+              <a:t>  —  當滑鼠完成拖曳拉線，接收 Connection (含 source, target)，建立真正的 Edge 並推入 edges 響應式陣列。</a:t>
+            </a:r>
+          </a:p>
+          <a:p>
+            <a:pPr>
+              <a:spcBef>
+                <a:spcPts val="500"/>
+              </a:spcBef>
+              <a:spcAft>
+                <a:spcPts val="300"/>
               </a:spcAft>
             </a:pPr>
             <a:r>
@@ -7229,16 +7212,16 @@
                   <a:srgbClr val="94A3B8"/>
                 </a:solidFill>
               </a:rPr>
-              <a:t>  —  提供視覺參考點與網格輔助，可以自訂間距（gap）與網格顏色（pattern-color）。</a:t>
-            </a:r>
-          </a:p>
-          <a:p>
-            <a:pPr>
-              <a:spcBef>
-                <a:spcPts val="600"/>
-              </a:spcBef>
-              <a:spcAft>
-                <a:spcPts val="400"/>
+              <a:t>  —  提供背景參考線，並能自訂網格點（gap）與自訂背景顏色。</a:t>
+            </a:r>
+          </a:p>
+          <a:p>
+            <a:pPr>
+              <a:spcBef>
+                <a:spcPts val="500"/>
+              </a:spcBef>
+              <a:spcAft>
+                <a:spcPts val="300"/>
               </a:spcAft>
             </a:pPr>
             <a:r>
@@ -7263,16 +7246,16 @@
                   <a:srgbClr val="94A3B8"/>
                 </a:solidFill>
               </a:rPr>
-              <a:t>  —  提供縮放（Zoom-in/out）、適配畫面（fit-view）以及鎖定（lock）功能的浮動控制列。</a:t>
-            </a:r>
-          </a:p>
-          <a:p>
-            <a:pPr>
-              <a:spcBef>
-                <a:spcPts val="600"/>
-              </a:spcBef>
-              <a:spcAft>
-                <a:spcPts val="400"/>
+              <a:t>  —  提供快捷功能，包含 Zoom in/out、適配畫面大小 (fitView) 以及防誤觸鎖定功能。</a:t>
+            </a:r>
+          </a:p>
+          <a:p>
+            <a:pPr>
+              <a:spcBef>
+                <a:spcPts val="500"/>
+              </a:spcBef>
+              <a:spcAft>
+                <a:spcPts val="300"/>
               </a:spcAft>
             </a:pPr>
             <a:r>
@@ -7297,7 +7280,7 @@
                   <a:srgbClr val="94A3B8"/>
                 </a:solidFill>
               </a:rPr>
-              <a:t>  —  在右下角提供一個全景的微型地圖，特別適合在大畫布的場景中進行全局定位。</a:t>
+              <a:t>  —  在右下角提供流程圖的全局微縮圖，以便在大規模節點中進行快速定位。</a:t>
             </a:r>
           </a:p>
         </p:txBody>

</xml_diff>

<commit_message>
refactor: use dynamic scoped slots for custom node rendering
</commit_message>
<xml_diff>
--- a/Vue-Flow-Simple-Tutorial.pptx
+++ b/Vue-Flow-Simple-Tutorial.pptx
@@ -5750,7 +5750,7 @@
               </a:defRPr>
             </a:pPr>
             <a:r>
-              <a:t>04  NODE REGISTRATION</a:t>
+              <a:t>04  DYNAMIC SCOPED SLOTS</a:t>
             </a:r>
           </a:p>
         </p:txBody>
@@ -5786,7 +5786,7 @@
               </a:defRPr>
             </a:pPr>
             <a:r>
-              <a:t>元件註冊與 markRaw 效能優化</a:t>
+              <a:t>使用作用域插槽進行自定義渲染</a:t>
             </a:r>
           </a:p>
         </p:txBody>
@@ -5973,7 +5973,7 @@
                 </a:solidFill>
                 <a:latin typeface="Consolas"/>
               </a:rPr>
-              <a:t> { ref, markRaw } from </a:t>
+              <a:t> { ref } from </a:t>
             </a:r>
             <a:r>
               <a:rPr sz="950">
@@ -6080,11 +6080,20 @@
             <a:r>
               <a:rPr sz="950">
                 <a:solidFill>
+                  <a:srgbClr val="C084FC"/>
+                </a:solidFill>
+                <a:latin typeface="Consolas"/>
+              </a:rPr>
+              <a:t>const</a:t>
+            </a:r>
+            <a:r>
+              <a:rPr sz="950">
+                <a:solidFill>
                   <a:srgbClr val="D4D4D8"/>
                 </a:solidFill>
                 <a:latin typeface="Consolas"/>
               </a:rPr>
-              <a:t/>
+              <a:t> nodes = ref(initialNodes)</a:t>
             </a:r>
           </a:p>
           <a:p>
@@ -6102,11 +6111,20 @@
             <a:r>
               <a:rPr sz="950">
                 <a:solidFill>
-                  <a:srgbClr val="64748B"/>
-                </a:solidFill>
-                <a:latin typeface="Consolas"/>
-              </a:rPr>
-              <a:t>/* ⚠️ 必須使用 markRaw 包裹以防止 Vue 深度 proxy 監聽，提升效能 */</a:t>
+                  <a:srgbClr val="C084FC"/>
+                </a:solidFill>
+                <a:latin typeface="Consolas"/>
+              </a:rPr>
+              <a:t>const</a:t>
+            </a:r>
+            <a:r>
+              <a:rPr sz="950">
+                <a:solidFill>
+                  <a:srgbClr val="D4D4D8"/>
+                </a:solidFill>
+                <a:latin typeface="Consolas"/>
+              </a:rPr>
+              <a:t> edges = ref(initialEdges)</a:t>
             </a:r>
           </a:p>
           <a:p>
@@ -6124,20 +6142,11 @@
             <a:r>
               <a:rPr sz="950">
                 <a:solidFill>
-                  <a:srgbClr val="C084FC"/>
-                </a:solidFill>
-                <a:latin typeface="Consolas"/>
-              </a:rPr>
-              <a:t>const</a:t>
-            </a:r>
-            <a:r>
-              <a:rPr sz="950">
-                <a:solidFill>
-                  <a:srgbClr val="D4D4D8"/>
-                </a:solidFill>
-                <a:latin typeface="Consolas"/>
-              </a:rPr>
-              <a:t> nodeTypes = {</a:t>
+                  <a:srgbClr val="FB7185"/>
+                </a:solidFill>
+                <a:latin typeface="Consolas"/>
+              </a:rPr>
+              <a:t>&lt;/script&gt;</a:t>
             </a:r>
           </a:p>
           <a:p>
@@ -6159,7 +6168,7 @@
                 </a:solidFill>
                 <a:latin typeface="Consolas"/>
               </a:rPr>
-              <a:t>  'simple-custom': markRaw(SimpleCustomNode),</a:t>
+              <a:t/>
             </a:r>
           </a:p>
           <a:p>
@@ -6177,11 +6186,11 @@
             <a:r>
               <a:rPr sz="950">
                 <a:solidFill>
-                  <a:srgbClr val="D4D4D8"/>
-                </a:solidFill>
-                <a:latin typeface="Consolas"/>
-              </a:rPr>
-              <a:t>}</a:t>
+                  <a:srgbClr val="FB7185"/>
+                </a:solidFill>
+                <a:latin typeface="Consolas"/>
+              </a:rPr>
+              <a:t>&lt;template&gt;</a:t>
             </a:r>
           </a:p>
           <a:p>
@@ -6203,7 +6212,79 @@
                 </a:solidFill>
                 <a:latin typeface="Consolas"/>
               </a:rPr>
-              <a:t>&lt;/script&gt;</a:t>
+              <a:t>  &lt;VueFlow </a:t>
+            </a:r>
+            <a:r>
+              <a:rPr sz="950">
+                <a:solidFill>
+                  <a:srgbClr val="818CF8"/>
+                </a:solidFill>
+                <a:latin typeface="Consolas"/>
+              </a:rPr>
+              <a:t>:nodes</a:t>
+            </a:r>
+            <a:r>
+              <a:rPr sz="950">
+                <a:solidFill>
+                  <a:srgbClr val="D4D4D8"/>
+                </a:solidFill>
+                <a:latin typeface="Consolas"/>
+              </a:rPr>
+              <a:t>=</a:t>
+            </a:r>
+            <a:r>
+              <a:rPr sz="950">
+                <a:solidFill>
+                  <a:srgbClr val="34D399"/>
+                </a:solidFill>
+                <a:latin typeface="Consolas"/>
+              </a:rPr>
+              <a:t>"nodes"</a:t>
+            </a:r>
+            <a:r>
+              <a:rPr sz="950">
+                <a:solidFill>
+                  <a:srgbClr val="D4D4D8"/>
+                </a:solidFill>
+                <a:latin typeface="Consolas"/>
+              </a:rPr>
+              <a:t> </a:t>
+            </a:r>
+            <a:r>
+              <a:rPr sz="950">
+                <a:solidFill>
+                  <a:srgbClr val="818CF8"/>
+                </a:solidFill>
+                <a:latin typeface="Consolas"/>
+              </a:rPr>
+              <a:t>:edges</a:t>
+            </a:r>
+            <a:r>
+              <a:rPr sz="950">
+                <a:solidFill>
+                  <a:srgbClr val="D4D4D8"/>
+                </a:solidFill>
+                <a:latin typeface="Consolas"/>
+              </a:rPr>
+              <a:t>=</a:t>
+            </a:r>
+            <a:r>
+              <a:rPr sz="950">
+                <a:solidFill>
+                  <a:srgbClr val="34D399"/>
+                </a:solidFill>
+                <a:latin typeface="Consolas"/>
+              </a:rPr>
+              <a:t>"edges"</a:t>
+            </a:r>
+            <a:r>
+              <a:rPr sz="950">
+                <a:solidFill>
+                  <a:srgbClr val="FB7185"/>
+                </a:solidFill>
+                <a:latin typeface="Consolas"/>
+              </a:rPr>
+              <a:t>&gt;</a:t>
             </a:r>
           </a:p>
           <a:p>
@@ -6221,11 +6302,11 @@
             <a:r>
               <a:rPr sz="950">
                 <a:solidFill>
-                  <a:srgbClr val="D4D4D8"/>
-                </a:solidFill>
-                <a:latin typeface="Consolas"/>
-              </a:rPr>
-              <a:t/>
+                  <a:srgbClr val="64748B"/>
+                </a:solidFill>
+                <a:latin typeface="Consolas"/>
+              </a:rPr>
+              <a:t>    &lt;!-- 💡 使用 #node-&lt;type&gt; 作用域插槽 --&gt;</a:t>
             </a:r>
           </a:p>
           <a:p>
@@ -6247,7 +6328,43 @@
                 </a:solidFill>
                 <a:latin typeface="Consolas"/>
               </a:rPr>
-              <a:t>&lt;template&gt;</a:t>
+              <a:t>    &lt;template </a:t>
+            </a:r>
+            <a:r>
+              <a:rPr sz="950">
+                <a:solidFill>
+                  <a:srgbClr val="818CF8"/>
+                </a:solidFill>
+                <a:latin typeface="Consolas"/>
+              </a:rPr>
+              <a:t>#node-simple-custom</a:t>
+            </a:r>
+            <a:r>
+              <a:rPr sz="950">
+                <a:solidFill>
+                  <a:srgbClr val="D4D4D8"/>
+                </a:solidFill>
+                <a:latin typeface="Consolas"/>
+              </a:rPr>
+              <a:t>=</a:t>
+            </a:r>
+            <a:r>
+              <a:rPr sz="950">
+                <a:solidFill>
+                  <a:srgbClr val="34D399"/>
+                </a:solidFill>
+                <a:latin typeface="Consolas"/>
+              </a:rPr>
+              <a:t>"nodeProps"</a:t>
+            </a:r>
+            <a:r>
+              <a:rPr sz="950">
+                <a:solidFill>
+                  <a:srgbClr val="FB7185"/>
+                </a:solidFill>
+                <a:latin typeface="Consolas"/>
+              </a:rPr>
+              <a:t>&gt;</a:t>
             </a:r>
           </a:p>
           <a:p>
@@ -6269,7 +6386,7 @@
                 </a:solidFill>
                 <a:latin typeface="Consolas"/>
               </a:rPr>
-              <a:t>  &lt;VueFlow </a:t>
+              <a:t>      &lt;SimpleCustomNode </a:t>
             </a:r>
             <a:r>
               <a:rPr sz="950">
@@ -6278,7 +6395,7 @@
                 </a:solidFill>
                 <a:latin typeface="Consolas"/>
               </a:rPr>
-              <a:t>:node-types</a:t>
+              <a:t>v-bind</a:t>
             </a:r>
             <a:r>
               <a:rPr sz="950">
@@ -6296,7 +6413,7 @@
                 </a:solidFill>
                 <a:latin typeface="Consolas"/>
               </a:rPr>
-              <a:t>"nodeTypes"</a:t>
+              <a:t>"nodeProps"</a:t>
             </a:r>
             <a:r>
               <a:rPr sz="950">
@@ -6305,7 +6422,51 @@
                 </a:solidFill>
                 <a:latin typeface="Consolas"/>
               </a:rPr>
-              <a:t> ... /&gt;</a:t>
+              <a:t> /&gt;</a:t>
+            </a:r>
+          </a:p>
+          <a:p>
+            <a:pPr>
+              <a:lnSpc>
+                <a:spcPts val="1400"/>
+              </a:lnSpc>
+              <a:spcBef>
+                <a:spcPts val="0"/>
+              </a:spcBef>
+              <a:spcAft>
+                <a:spcPts val="0"/>
+              </a:spcAft>
+            </a:pPr>
+            <a:r>
+              <a:rPr sz="950">
+                <a:solidFill>
+                  <a:srgbClr val="FB7185"/>
+                </a:solidFill>
+                <a:latin typeface="Consolas"/>
+              </a:rPr>
+              <a:t>    &lt;/template&gt;</a:t>
+            </a:r>
+          </a:p>
+          <a:p>
+            <a:pPr>
+              <a:lnSpc>
+                <a:spcPts val="1400"/>
+              </a:lnSpc>
+              <a:spcBef>
+                <a:spcPts val="0"/>
+              </a:spcBef>
+              <a:spcAft>
+                <a:spcPts val="0"/>
+              </a:spcAft>
+            </a:pPr>
+            <a:r>
+              <a:rPr sz="950">
+                <a:solidFill>
+                  <a:srgbClr val="FB7185"/>
+                </a:solidFill>
+                <a:latin typeface="Consolas"/>
+              </a:rPr>
+              <a:t>  &lt;/VueFlow&gt;</a:t>
             </a:r>
           </a:p>
           <a:p>
@@ -6368,7 +6529,7 @@
                   <a:srgbClr val="10B981"/>
                 </a:solidFill>
               </a:rPr>
-              <a:t>⚠️  </a:t>
+              <a:t>💡  </a:t>
             </a:r>
             <a:r>
               <a:rPr sz="1450" b="1">
@@ -6376,7 +6537,7 @@
                   <a:srgbClr val="F8FAFC"/>
                 </a:solidFill>
               </a:rPr>
-              <a:t>效能關鍵：markRaw()</a:t>
+              <a:t>動態插槽命名規範</a:t>
             </a:r>
             <a:r>
               <a:rPr sz="1300">
@@ -6384,7 +6545,7 @@
                   <a:srgbClr val="94A3B8"/>
                 </a:solidFill>
               </a:rPr>
-              <a:t>  —  Vue 3 預設會遞迴地將所有 reactive 變數轉為 Proxy。若不使用 markRaw，Vue Flow 內部的節點實例會被頻繁 Proxy 處理，導致拖拽時嚴重卡頓與效能損耗。</a:t>
+              <a:t>  —  Vue Flow 為每種節點型態提供了 `#node-&lt;type&gt;` 格式的作用域插槽，方便針對特定節點類型進行個別化定制。</a:t>
             </a:r>
           </a:p>
           <a:p>
@@ -6402,7 +6563,7 @@
                   <a:srgbClr val="10B981"/>
                 </a:solidFill>
               </a:rPr>
-              <a:t>🏷️  </a:t>
+              <a:t>⚡  </a:t>
             </a:r>
             <a:r>
               <a:rPr sz="1450" b="1">
@@ -6410,7 +6571,7 @@
                   <a:srgbClr val="F8FAFC"/>
                 </a:solidFill>
               </a:rPr>
-              <a:t>自訂 nodeTypes 對應</a:t>
+              <a:t>無需手動註冊與 markRaw</a:t>
             </a:r>
             <a:r>
               <a:rPr sz="1300">
@@ -6418,7 +6579,7 @@
                   <a:srgbClr val="94A3B8"/>
                 </a:solidFill>
               </a:rPr>
-              <a:t>  —  以 key-value 形式對應自訂名稱與元件。在 initial-elements.ts 中只需宣告 type: 'simple-custom' 即可。</a:t>
+              <a:t>  —  使用插槽形式直接在 template 引入組件，不再需要於 script 中使用 nodeTypes 註冊或呼叫 markRaw()，代碼更加簡潔。</a:t>
             </a:r>
           </a:p>
           <a:p>
@@ -6436,7 +6597,7 @@
                   <a:srgbClr val="10B981"/>
                 </a:solidFill>
               </a:rPr>
-              <a:t>⚡  </a:t>
+              <a:t>📦  </a:t>
             </a:r>
             <a:r>
               <a:rPr sz="1450" b="1">
@@ -6444,7 +6605,7 @@
                   <a:srgbClr val="F8FAFC"/>
                 </a:solidFill>
               </a:rPr>
-              <a:t>資料傳遞方式</a:t>
+              <a:t>屬性傳遞：v-bind="nodeProps"</a:t>
             </a:r>
             <a:r>
               <a:rPr sz="1300">
@@ -6452,7 +6613,7 @@
                   <a:srgbClr val="94A3B8"/>
                 </a:solidFill>
               </a:rPr>
-              <a:t>  —  在 nodes 資料定義中的 data 欄位，會自動作為 props 被傳遞至自定義元件內部。</a:t>
+              <a:t>  —  插槽會傳遞該節點的完整配置與狀態 (如 id, data, selected)，可直接透過 v-bind 轉交給子組件。</a:t>
             </a:r>
           </a:p>
         </p:txBody>

</xml_diff>